<commit_message>
Finish validated voice planning and hackathon release assets
</commit_message>
<xml_diff>
--- a/submission/carethread-deck.pptx
+++ b/submission/carethread-deck.pptx
@@ -2,20 +2,20 @@
 <file path=ppt/presentation.xml><?xml version="1.0" encoding="utf-8"?>
 <p:presentation xmlns:p="http://schemas.openxmlformats.org/presentationml/2006/main">
   <p:sldMasterIdLst>
-    <p:sldMasterId xmlns:r="http://schemas.openxmlformats.org/officeDocument/2006/relationships" id="2147483648" r:id="R34f8d49e994c4c7f"/>
+    <p:sldMasterId xmlns:r="http://schemas.openxmlformats.org/officeDocument/2006/relationships" id="2147483648" r:id="R8a161b5a62ac45bf"/>
   </p:sldMasterIdLst>
   <p:notesMasterIdLst>
-    <p:notesMasterId xmlns:r="http://schemas.openxmlformats.org/officeDocument/2006/relationships" r:id="R051955d73b3e4caa"/>
+    <p:notesMasterId xmlns:r="http://schemas.openxmlformats.org/officeDocument/2006/relationships" r:id="R89e661c7f6f4482c"/>
   </p:notesMasterIdLst>
   <p:sldIdLst>
-    <p:sldId xmlns:r="http://schemas.openxmlformats.org/officeDocument/2006/relationships" id="256" r:id="R56cdb55c552e447a"/>
-    <p:sldId xmlns:r="http://schemas.openxmlformats.org/officeDocument/2006/relationships" id="257" r:id="Rb862e884cf9c4c65"/>
-    <p:sldId xmlns:r="http://schemas.openxmlformats.org/officeDocument/2006/relationships" id="258" r:id="R5e6e39b89f4a4290"/>
-    <p:sldId xmlns:r="http://schemas.openxmlformats.org/officeDocument/2006/relationships" id="259" r:id="R33a6fe1184944333"/>
-    <p:sldId xmlns:r="http://schemas.openxmlformats.org/officeDocument/2006/relationships" id="260" r:id="R29f2f867602246a4"/>
-    <p:sldId xmlns:r="http://schemas.openxmlformats.org/officeDocument/2006/relationships" id="261" r:id="R96cacb03ab2f4469"/>
-    <p:sldId xmlns:r="http://schemas.openxmlformats.org/officeDocument/2006/relationships" id="262" r:id="R617b2c7e29b44a95"/>
-    <p:sldId xmlns:r="http://schemas.openxmlformats.org/officeDocument/2006/relationships" id="263" r:id="R7178bf69fe4449da"/>
+    <p:sldId xmlns:r="http://schemas.openxmlformats.org/officeDocument/2006/relationships" id="256" r:id="Rb1dd03fa91db41d2"/>
+    <p:sldId xmlns:r="http://schemas.openxmlformats.org/officeDocument/2006/relationships" id="257" r:id="R7040605081324ea6"/>
+    <p:sldId xmlns:r="http://schemas.openxmlformats.org/officeDocument/2006/relationships" id="258" r:id="Ra54044cc44d74dda"/>
+    <p:sldId xmlns:r="http://schemas.openxmlformats.org/officeDocument/2006/relationships" id="259" r:id="R0535c59cb5d442ed"/>
+    <p:sldId xmlns:r="http://schemas.openxmlformats.org/officeDocument/2006/relationships" id="260" r:id="Rfd3b952962e74a9a"/>
+    <p:sldId xmlns:r="http://schemas.openxmlformats.org/officeDocument/2006/relationships" id="261" r:id="R3fd3b07b550e485a"/>
+    <p:sldId xmlns:r="http://schemas.openxmlformats.org/officeDocument/2006/relationships" id="262" r:id="R1a8ce1fcfd644921"/>
+    <p:sldId xmlns:r="http://schemas.openxmlformats.org/officeDocument/2006/relationships" id="263" r:id="R1305b64143a04f4d"/>
   </p:sldIdLst>
   <p:sldSz cx="12192000" cy="6858000"/>
   <p:notesSz cx="6858000" cy="9144000"/>
@@ -729,7 +729,7 @@
           <a:lstStyle xmlns:a="http://schemas.openxmlformats.org/drawingml/2006/main"/>
           <a:p xmlns:a="http://schemas.openxmlformats.org/drawingml/2006/main">
             <a:r>
-              <a:t>Architecture per build plan: Next.js, React, TypeScript, AssemblyAI managed Voice Agent API, server-side token endpoint and same-browser persistence. https://www.assemblyai.com/docs/voice-agents/voice-agent-api/browser-integration ; https://www.assemblyai.com/docs/voice-agents/voice-agent-api/tools/client-side-tools . Local persistence does not imply offline voice processing or a hospital-grade privacy system.</a:t>
+              <a:t>Verified implemented architecture: AssemblyAI managed Voice Agent API handles speech and conversational replies with tools: []. Each final human transcript is analyzed by a server-side AssemblyAI LLM Gateway JSON planner, using qwen3.5-4b-32k-fast. Deterministic state validation applies source-linked proposals. The model does not directly mutate app state. Same-browser IndexedDB persistence and exports. https://www.assemblyai.com/docs/voice-agents/voice-agent-api/browser-integration ; https://www.assemblyai.com/docs/llm-gateway/quickstart . Local persistence does not imply offline processing or hospital suitability. One synthetic audio fixture passed the full speech-to-board path in qa/integrated-voice-result.json.</a:t>
             </a:r>
           </a:p>
         </p:txBody>
@@ -869,7 +869,7 @@
           <a:lstStyle xmlns:a="http://schemas.openxmlformats.org/drawingml/2006/main"/>
           <a:p xmlns:a="http://schemas.openxmlformats.org/drawingml/2006/main">
             <a:r>
-              <a:t>{"status":"recorded","headline":"20 deterministic tests passed","lines":["State-engine checks: 20 / 20 passing","Voice session connected; full flow still under review","Clinical outcomes and live reliability: not established"],"evidence_note":"Parent reported npm test 20/20 deterministic state-engine tests passed; npm run typecheck passed at this stage; valid token and session.ready confirmed. Synthetic speech transcribed a complete dictated task. End-to-end tool behavior, interruption/latency measurements, and clinical validity were not established by this report. No miss-rate or false-alert percentages are claimed.","source":"Parent verification, 2026-09-30"}</a:t>
+              <a:t>{"status":"recorded","headline":"78 automated checks passed","lines":["State, storage, access and planner checks passed","One synthetic spoken fixture reached validated board state","Device microphone and clinical reliability remain unvalidated"],"evidence_note":"Implementation lead verified 78 automated checks across state rules, saved-record validation, token access, planner validation and the analysis route, including nested cases. qa/integrated-voice-result.json records one successful synthetic audio fixture through the AssemblyAI managed Voice Agent transcript, server-side AssemblyAI LLM Gateway JSON proposal and deterministic board validation. The correct task, owner, timing, stated condition and pending uncertainty were captured as an unreviewed pending item. AssemblyAI also returned spoken audio asking for review. This was a generated audio fixture, not a person using the browser microphone. Three separate Gateway cases (capture, confirmation and acknowledgment) passed; a rapid request encountered 429 before a spaced retry passed. No clinical benefit, general reliability, false-alert rate or latency benchmark is claimed.","source":"qa/integrated-voice-result.json, qa/gateway-smoke.json and implementation-lead verification, 2026-09-30"}</a:t>
             </a:r>
           </a:p>
           <a:p xmlns:a="http://schemas.openxmlformats.org/drawingml/2006/main">
@@ -977,6 +977,1561 @@
 <file path=ppt/slideLayouts/slideLayout1.xml><?xml version="1.0" encoding="utf-8"?>
 <p:sldLayout xmlns:p="http://schemas.openxmlformats.org/presentationml/2006/main" type="title">
   <p:cSld name="Title Slide">
+    <p:spTree>
+      <p:nvGrpSpPr>
+        <p:cNvPr id="1" name=""/>
+        <p:cNvGrpSpPr/>
+        <p:nvPr/>
+      </p:nvGrpSpPr>
+      <p:grpSpPr>
+        <a:xfrm xmlns:a="http://schemas.openxmlformats.org/drawingml/2006/main"/>
+      </p:grpSpPr>
+      <p:sp>
+        <p:nvSpPr>
+          <p:cNvPr id="3" name="Title">
+            <a:extLst xmlns:a="http://schemas.openxmlformats.org/drawingml/2006/main">
+              <a:ext uri="{FF2B5EF4-FFF2-40B4-BE49-F238E27FC236}">
+                <a16:creationId xmlns:a16="http://schemas.microsoft.com/office/drawing/2014/main" id="{584646AE-9569-4F96-B06E-3010F0859AD7}"/>
+              </a:ext>
+            </a:extLst>
+          </p:cNvPr>
+          <p:cNvSpPr>
+            <a:spLocks xmlns:a="http://schemas.openxmlformats.org/drawingml/2006/main" noGrp="1"/>
+          </p:cNvSpPr>
+          <p:nvPr>
+            <p:ph type="title" idx="0"/>
+          </p:nvPr>
+        </p:nvSpPr>
+        <p:spPr>
+          <a:xfrm xmlns:a="http://schemas.openxmlformats.org/drawingml/2006/main">
+            <a:off x="1219200" y="2590800"/>
+            <a:ext cx="9753600" cy="990600"/>
+          </a:xfrm>
+          <a:prstGeom xmlns:a="http://schemas.openxmlformats.org/drawingml/2006/main" prst="rect">
+            <a:avLst/>
+          </a:prstGeom>
+          <a:noFill xmlns:a="http://schemas.openxmlformats.org/drawingml/2006/main"/>
+          <a:ln xmlns:a="http://schemas.openxmlformats.org/drawingml/2006/main">
+            <a:noFill/>
+            <a:prstDash val="solid"/>
+          </a:ln>
+        </p:spPr>
+        <p:txBody>
+          <a:bodyPr xmlns:a="http://schemas.openxmlformats.org/drawingml/2006/main" wrap="square" lIns="0" tIns="0" rIns="0" bIns="0" anchor="ctr">
+            <a:normAutofit/>
+          </a:bodyPr>
+          <a:lstStyle xmlns:a="http://schemas.openxmlformats.org/drawingml/2006/main">
+            <a:lvl1pPr marL="0" indent="0">
+              <a:lnSpc>
+                <a:spcPct val="110000"/>
+              </a:lnSpc>
+              <a:spcBef>
+                <a:spcPts val="0"/>
+              </a:spcBef>
+              <a:spcAft>
+                <a:spcPts val="0"/>
+              </a:spcAft>
+              <a:buNone/>
+            </a:lvl1pPr>
+            <a:lvl2pPr marL="0" indent="0">
+              <a:lnSpc>
+                <a:spcPct val="110000"/>
+              </a:lnSpc>
+              <a:spcBef>
+                <a:spcPts val="0"/>
+              </a:spcBef>
+              <a:spcAft>
+                <a:spcPts val="0"/>
+              </a:spcAft>
+              <a:buNone/>
+            </a:lvl2pPr>
+            <a:lvl3pPr marL="0" indent="0">
+              <a:lnSpc>
+                <a:spcPct val="110000"/>
+              </a:lnSpc>
+              <a:spcBef>
+                <a:spcPts val="0"/>
+              </a:spcBef>
+              <a:spcAft>
+                <a:spcPts val="0"/>
+              </a:spcAft>
+              <a:buNone/>
+            </a:lvl3pPr>
+            <a:lvl4pPr marL="0" indent="0">
+              <a:lnSpc>
+                <a:spcPct val="110000"/>
+              </a:lnSpc>
+              <a:spcBef>
+                <a:spcPts val="0"/>
+              </a:spcBef>
+              <a:spcAft>
+                <a:spcPts val="0"/>
+              </a:spcAft>
+              <a:buNone/>
+            </a:lvl4pPr>
+            <a:lvl5pPr marL="0" indent="0">
+              <a:lnSpc>
+                <a:spcPct val="110000"/>
+              </a:lnSpc>
+              <a:spcBef>
+                <a:spcPts val="0"/>
+              </a:spcBef>
+              <a:spcAft>
+                <a:spcPts val="0"/>
+              </a:spcAft>
+              <a:buNone/>
+            </a:lvl5pPr>
+            <a:lvl6pPr marL="0" indent="0">
+              <a:lnSpc>
+                <a:spcPct val="110000"/>
+              </a:lnSpc>
+              <a:spcBef>
+                <a:spcPts val="0"/>
+              </a:spcBef>
+              <a:spcAft>
+                <a:spcPts val="0"/>
+              </a:spcAft>
+              <a:buNone/>
+            </a:lvl6pPr>
+            <a:lvl7pPr marL="0" indent="0">
+              <a:lnSpc>
+                <a:spcPct val="110000"/>
+              </a:lnSpc>
+              <a:spcBef>
+                <a:spcPts val="0"/>
+              </a:spcBef>
+              <a:spcAft>
+                <a:spcPts val="0"/>
+              </a:spcAft>
+              <a:buNone/>
+            </a:lvl7pPr>
+            <a:lvl8pPr marL="0" indent="0">
+              <a:lnSpc>
+                <a:spcPct val="110000"/>
+              </a:lnSpc>
+              <a:spcBef>
+                <a:spcPts val="0"/>
+              </a:spcBef>
+              <a:spcAft>
+                <a:spcPts val="0"/>
+              </a:spcAft>
+              <a:buNone/>
+            </a:lvl8pPr>
+            <a:lvl9pPr marL="0" indent="0">
+              <a:lnSpc>
+                <a:spcPct val="110000"/>
+              </a:lnSpc>
+              <a:spcBef>
+                <a:spcPts val="0"/>
+              </a:spcBef>
+              <a:spcAft>
+                <a:spcPts val="0"/>
+              </a:spcAft>
+              <a:buNone/>
+            </a:lvl9pPr>
+          </a:lstStyle>
+          <a:p xmlns:a="http://schemas.openxmlformats.org/drawingml/2006/main"/>
+        </p:txBody>
+      </p:sp>
+      <p:sp>
+        <p:nvSpPr>
+          <p:cNvPr id="2" name="Subtitle">
+            <a:extLst xmlns:a="http://schemas.openxmlformats.org/drawingml/2006/main">
+              <a:ext uri="{FF2B5EF4-FFF2-40B4-BE49-F238E27FC236}">
+                <a16:creationId xmlns:a16="http://schemas.microsoft.com/office/drawing/2014/main" id="{520DB21B-A796-4513-BEB8-08083DED3F2C}"/>
+              </a:ext>
+            </a:extLst>
+          </p:cNvPr>
+          <p:cNvSpPr>
+            <a:spLocks xmlns:a="http://schemas.openxmlformats.org/drawingml/2006/main" noGrp="1"/>
+          </p:cNvSpPr>
+          <p:nvPr>
+            <p:ph type="subTitle" idx="1"/>
+          </p:nvPr>
+        </p:nvSpPr>
+        <p:spPr>
+          <a:xfrm xmlns:a="http://schemas.openxmlformats.org/drawingml/2006/main">
+            <a:off x="1828800" y="3771900"/>
+            <a:ext cx="8534400" cy="762000"/>
+          </a:xfrm>
+          <a:prstGeom xmlns:a="http://schemas.openxmlformats.org/drawingml/2006/main" prst="rect">
+            <a:avLst/>
+          </a:prstGeom>
+          <a:noFill xmlns:a="http://schemas.openxmlformats.org/drawingml/2006/main"/>
+          <a:ln xmlns:a="http://schemas.openxmlformats.org/drawingml/2006/main">
+            <a:noFill/>
+            <a:prstDash val="solid"/>
+          </a:ln>
+        </p:spPr>
+        <p:txBody>
+          <a:bodyPr xmlns:a="http://schemas.openxmlformats.org/drawingml/2006/main" wrap="square" lIns="0" tIns="0" rIns="0" bIns="0" anchor="ctr">
+            <a:normAutofit/>
+          </a:bodyPr>
+          <a:lstStyle xmlns:a="http://schemas.openxmlformats.org/drawingml/2006/main">
+            <a:lvl1pPr marL="0" indent="0">
+              <a:lnSpc>
+                <a:spcPct val="110000"/>
+              </a:lnSpc>
+              <a:spcBef>
+                <a:spcPts val="0"/>
+              </a:spcBef>
+              <a:spcAft>
+                <a:spcPts val="0"/>
+              </a:spcAft>
+              <a:buNone/>
+            </a:lvl1pPr>
+            <a:lvl2pPr marL="0" indent="0">
+              <a:lnSpc>
+                <a:spcPct val="110000"/>
+              </a:lnSpc>
+              <a:spcBef>
+                <a:spcPts val="0"/>
+              </a:spcBef>
+              <a:spcAft>
+                <a:spcPts val="0"/>
+              </a:spcAft>
+              <a:buNone/>
+            </a:lvl2pPr>
+            <a:lvl3pPr marL="0" indent="0">
+              <a:lnSpc>
+                <a:spcPct val="110000"/>
+              </a:lnSpc>
+              <a:spcBef>
+                <a:spcPts val="0"/>
+              </a:spcBef>
+              <a:spcAft>
+                <a:spcPts val="0"/>
+              </a:spcAft>
+              <a:buNone/>
+            </a:lvl3pPr>
+            <a:lvl4pPr marL="0" indent="0">
+              <a:lnSpc>
+                <a:spcPct val="110000"/>
+              </a:lnSpc>
+              <a:spcBef>
+                <a:spcPts val="0"/>
+              </a:spcBef>
+              <a:spcAft>
+                <a:spcPts val="0"/>
+              </a:spcAft>
+              <a:buNone/>
+            </a:lvl4pPr>
+            <a:lvl5pPr marL="0" indent="0">
+              <a:lnSpc>
+                <a:spcPct val="110000"/>
+              </a:lnSpc>
+              <a:spcBef>
+                <a:spcPts val="0"/>
+              </a:spcBef>
+              <a:spcAft>
+                <a:spcPts val="0"/>
+              </a:spcAft>
+              <a:buNone/>
+            </a:lvl5pPr>
+            <a:lvl6pPr marL="0" indent="0">
+              <a:lnSpc>
+                <a:spcPct val="110000"/>
+              </a:lnSpc>
+              <a:spcBef>
+                <a:spcPts val="0"/>
+              </a:spcBef>
+              <a:spcAft>
+                <a:spcPts val="0"/>
+              </a:spcAft>
+              <a:buNone/>
+            </a:lvl6pPr>
+            <a:lvl7pPr marL="0" indent="0">
+              <a:lnSpc>
+                <a:spcPct val="110000"/>
+              </a:lnSpc>
+              <a:spcBef>
+                <a:spcPts val="0"/>
+              </a:spcBef>
+              <a:spcAft>
+                <a:spcPts val="0"/>
+              </a:spcAft>
+              <a:buNone/>
+            </a:lvl7pPr>
+            <a:lvl8pPr marL="0" indent="0">
+              <a:lnSpc>
+                <a:spcPct val="110000"/>
+              </a:lnSpc>
+              <a:spcBef>
+                <a:spcPts val="0"/>
+              </a:spcBef>
+              <a:spcAft>
+                <a:spcPts val="0"/>
+              </a:spcAft>
+              <a:buNone/>
+            </a:lvl8pPr>
+            <a:lvl9pPr marL="0" indent="0">
+              <a:lnSpc>
+                <a:spcPct val="110000"/>
+              </a:lnSpc>
+              <a:spcBef>
+                <a:spcPts val="0"/>
+              </a:spcBef>
+              <a:spcAft>
+                <a:spcPts val="0"/>
+              </a:spcAft>
+              <a:buNone/>
+            </a:lvl9pPr>
+          </a:lstStyle>
+          <a:p xmlns:a="http://schemas.openxmlformats.org/drawingml/2006/main"/>
+        </p:txBody>
+      </p:sp>
+    </p:spTree>
+  </p:cSld>
+</p:sldLayout>
+</file>
+
+<file path=ppt/slideLayouts/slideLayout2.xml><?xml version="1.0" encoding="utf-8"?>
+<p:sldLayout xmlns:p="http://schemas.openxmlformats.org/presentationml/2006/main">
+  <p:cSld name="Section Header">
+    <p:spTree>
+      <p:nvGrpSpPr>
+        <p:cNvPr id="1" name=""/>
+        <p:cNvGrpSpPr/>
+        <p:nvPr/>
+      </p:nvGrpSpPr>
+      <p:grpSpPr>
+        <a:xfrm xmlns:a="http://schemas.openxmlformats.org/drawingml/2006/main"/>
+      </p:grpSpPr>
+      <p:sp>
+        <p:nvSpPr>
+          <p:cNvPr id="2" name="Section title">
+            <a:extLst xmlns:a="http://schemas.openxmlformats.org/drawingml/2006/main">
+              <a:ext uri="{FF2B5EF4-FFF2-40B4-BE49-F238E27FC236}">
+                <a16:creationId xmlns:a16="http://schemas.microsoft.com/office/drawing/2014/main" id="{7FF3DE98-2D65-4A71-BA1F-AD7936A3EF52}"/>
+              </a:ext>
+            </a:extLst>
+          </p:cNvPr>
+          <p:cNvSpPr>
+            <a:spLocks xmlns:a="http://schemas.openxmlformats.org/drawingml/2006/main" noGrp="1"/>
+          </p:cNvSpPr>
+          <p:nvPr>
+            <p:ph type="title" idx="0"/>
+          </p:nvPr>
+        </p:nvSpPr>
+        <p:spPr>
+          <a:xfrm xmlns:a="http://schemas.openxmlformats.org/drawingml/2006/main">
+            <a:off x="1219200" y="2857500"/>
+            <a:ext cx="9753600" cy="1143000"/>
+          </a:xfrm>
+          <a:prstGeom xmlns:a="http://schemas.openxmlformats.org/drawingml/2006/main" prst="rect">
+            <a:avLst/>
+          </a:prstGeom>
+          <a:noFill xmlns:a="http://schemas.openxmlformats.org/drawingml/2006/main"/>
+          <a:ln xmlns:a="http://schemas.openxmlformats.org/drawingml/2006/main">
+            <a:noFill/>
+            <a:prstDash val="solid"/>
+          </a:ln>
+        </p:spPr>
+        <p:txBody>
+          <a:bodyPr xmlns:a="http://schemas.openxmlformats.org/drawingml/2006/main" wrap="square" lIns="0" tIns="0" rIns="0" bIns="0" anchor="ctr">
+            <a:normAutofit/>
+          </a:bodyPr>
+          <a:lstStyle xmlns:a="http://schemas.openxmlformats.org/drawingml/2006/main">
+            <a:lvl1pPr marL="0" indent="0">
+              <a:lnSpc>
+                <a:spcPct val="110000"/>
+              </a:lnSpc>
+              <a:spcBef>
+                <a:spcPts val="0"/>
+              </a:spcBef>
+              <a:spcAft>
+                <a:spcPts val="0"/>
+              </a:spcAft>
+              <a:buNone/>
+            </a:lvl1pPr>
+            <a:lvl2pPr marL="0" indent="0">
+              <a:lnSpc>
+                <a:spcPct val="110000"/>
+              </a:lnSpc>
+              <a:spcBef>
+                <a:spcPts val="0"/>
+              </a:spcBef>
+              <a:spcAft>
+                <a:spcPts val="0"/>
+              </a:spcAft>
+              <a:buNone/>
+            </a:lvl2pPr>
+            <a:lvl3pPr marL="0" indent="0">
+              <a:lnSpc>
+                <a:spcPct val="110000"/>
+              </a:lnSpc>
+              <a:spcBef>
+                <a:spcPts val="0"/>
+              </a:spcBef>
+              <a:spcAft>
+                <a:spcPts val="0"/>
+              </a:spcAft>
+              <a:buNone/>
+            </a:lvl3pPr>
+            <a:lvl4pPr marL="0" indent="0">
+              <a:lnSpc>
+                <a:spcPct val="110000"/>
+              </a:lnSpc>
+              <a:spcBef>
+                <a:spcPts val="0"/>
+              </a:spcBef>
+              <a:spcAft>
+                <a:spcPts val="0"/>
+              </a:spcAft>
+              <a:buNone/>
+            </a:lvl4pPr>
+            <a:lvl5pPr marL="0" indent="0">
+              <a:lnSpc>
+                <a:spcPct val="110000"/>
+              </a:lnSpc>
+              <a:spcBef>
+                <a:spcPts val="0"/>
+              </a:spcBef>
+              <a:spcAft>
+                <a:spcPts val="0"/>
+              </a:spcAft>
+              <a:buNone/>
+            </a:lvl5pPr>
+            <a:lvl6pPr marL="0" indent="0">
+              <a:lnSpc>
+                <a:spcPct val="110000"/>
+              </a:lnSpc>
+              <a:spcBef>
+                <a:spcPts val="0"/>
+              </a:spcBef>
+              <a:spcAft>
+                <a:spcPts val="0"/>
+              </a:spcAft>
+              <a:buNone/>
+            </a:lvl6pPr>
+            <a:lvl7pPr marL="0" indent="0">
+              <a:lnSpc>
+                <a:spcPct val="110000"/>
+              </a:lnSpc>
+              <a:spcBef>
+                <a:spcPts val="0"/>
+              </a:spcBef>
+              <a:spcAft>
+                <a:spcPts val="0"/>
+              </a:spcAft>
+              <a:buNone/>
+            </a:lvl7pPr>
+            <a:lvl8pPr marL="0" indent="0">
+              <a:lnSpc>
+                <a:spcPct val="110000"/>
+              </a:lnSpc>
+              <a:spcBef>
+                <a:spcPts val="0"/>
+              </a:spcBef>
+              <a:spcAft>
+                <a:spcPts val="0"/>
+              </a:spcAft>
+              <a:buNone/>
+            </a:lvl8pPr>
+            <a:lvl9pPr marL="0" indent="0">
+              <a:lnSpc>
+                <a:spcPct val="110000"/>
+              </a:lnSpc>
+              <a:spcBef>
+                <a:spcPts val="0"/>
+              </a:spcBef>
+              <a:spcAft>
+                <a:spcPts val="0"/>
+              </a:spcAft>
+              <a:buNone/>
+            </a:lvl9pPr>
+          </a:lstStyle>
+          <a:p xmlns:a="http://schemas.openxmlformats.org/drawingml/2006/main"/>
+        </p:txBody>
+      </p:sp>
+    </p:spTree>
+  </p:cSld>
+</p:sldLayout>
+</file>
+
+<file path=ppt/slideLayouts/slideLayout3.xml><?xml version="1.0" encoding="utf-8"?>
+<p:sldLayout xmlns:p="http://schemas.openxmlformats.org/presentationml/2006/main">
+  <p:cSld name="Title and Body">
+    <p:spTree>
+      <p:nvGrpSpPr>
+        <p:cNvPr id="1" name=""/>
+        <p:cNvGrpSpPr/>
+        <p:nvPr/>
+      </p:nvGrpSpPr>
+      <p:grpSpPr>
+        <a:xfrm xmlns:a="http://schemas.openxmlformats.org/drawingml/2006/main"/>
+      </p:grpSpPr>
+      <p:sp>
+        <p:nvSpPr>
+          <p:cNvPr id="3" name="Title">
+            <a:extLst xmlns:a="http://schemas.openxmlformats.org/drawingml/2006/main">
+              <a:ext uri="{FF2B5EF4-FFF2-40B4-BE49-F238E27FC236}">
+                <a16:creationId xmlns:a16="http://schemas.microsoft.com/office/drawing/2014/main" id="{0141C8BD-E61C-4279-8D97-B59030585E1F}"/>
+              </a:ext>
+            </a:extLst>
+          </p:cNvPr>
+          <p:cNvSpPr>
+            <a:spLocks xmlns:a="http://schemas.openxmlformats.org/drawingml/2006/main" noGrp="1"/>
+          </p:cNvSpPr>
+          <p:nvPr>
+            <p:ph type="title" idx="0"/>
+          </p:nvPr>
+        </p:nvSpPr>
+        <p:spPr>
+          <a:xfrm xmlns:a="http://schemas.openxmlformats.org/drawingml/2006/main">
+            <a:off x="685800" y="533400"/>
+            <a:ext cx="10820400" cy="838200"/>
+          </a:xfrm>
+          <a:prstGeom xmlns:a="http://schemas.openxmlformats.org/drawingml/2006/main" prst="rect">
+            <a:avLst/>
+          </a:prstGeom>
+          <a:noFill xmlns:a="http://schemas.openxmlformats.org/drawingml/2006/main"/>
+          <a:ln xmlns:a="http://schemas.openxmlformats.org/drawingml/2006/main">
+            <a:noFill/>
+            <a:prstDash val="solid"/>
+          </a:ln>
+        </p:spPr>
+        <p:txBody>
+          <a:bodyPr xmlns:a="http://schemas.openxmlformats.org/drawingml/2006/main" wrap="square" lIns="0" tIns="0" rIns="0" bIns="0" anchor="t">
+            <a:normAutofit/>
+          </a:bodyPr>
+          <a:lstStyle xmlns:a="http://schemas.openxmlformats.org/drawingml/2006/main">
+            <a:lvl1pPr marL="0" indent="0">
+              <a:lnSpc>
+                <a:spcPct val="110000"/>
+              </a:lnSpc>
+              <a:spcBef>
+                <a:spcPts val="0"/>
+              </a:spcBef>
+              <a:spcAft>
+                <a:spcPts val="0"/>
+              </a:spcAft>
+              <a:buNone/>
+            </a:lvl1pPr>
+            <a:lvl2pPr marL="0" indent="0">
+              <a:lnSpc>
+                <a:spcPct val="110000"/>
+              </a:lnSpc>
+              <a:spcBef>
+                <a:spcPts val="0"/>
+              </a:spcBef>
+              <a:spcAft>
+                <a:spcPts val="0"/>
+              </a:spcAft>
+              <a:buNone/>
+            </a:lvl2pPr>
+            <a:lvl3pPr marL="0" indent="0">
+              <a:lnSpc>
+                <a:spcPct val="110000"/>
+              </a:lnSpc>
+              <a:spcBef>
+                <a:spcPts val="0"/>
+              </a:spcBef>
+              <a:spcAft>
+                <a:spcPts val="0"/>
+              </a:spcAft>
+              <a:buNone/>
+            </a:lvl3pPr>
+            <a:lvl4pPr marL="0" indent="0">
+              <a:lnSpc>
+                <a:spcPct val="110000"/>
+              </a:lnSpc>
+              <a:spcBef>
+                <a:spcPts val="0"/>
+              </a:spcBef>
+              <a:spcAft>
+                <a:spcPts val="0"/>
+              </a:spcAft>
+              <a:buNone/>
+            </a:lvl4pPr>
+            <a:lvl5pPr marL="0" indent="0">
+              <a:lnSpc>
+                <a:spcPct val="110000"/>
+              </a:lnSpc>
+              <a:spcBef>
+                <a:spcPts val="0"/>
+              </a:spcBef>
+              <a:spcAft>
+                <a:spcPts val="0"/>
+              </a:spcAft>
+              <a:buNone/>
+            </a:lvl5pPr>
+            <a:lvl6pPr marL="0" indent="0">
+              <a:lnSpc>
+                <a:spcPct val="110000"/>
+              </a:lnSpc>
+              <a:spcBef>
+                <a:spcPts val="0"/>
+              </a:spcBef>
+              <a:spcAft>
+                <a:spcPts val="0"/>
+              </a:spcAft>
+              <a:buNone/>
+            </a:lvl6pPr>
+            <a:lvl7pPr marL="0" indent="0">
+              <a:lnSpc>
+                <a:spcPct val="110000"/>
+              </a:lnSpc>
+              <a:spcBef>
+                <a:spcPts val="0"/>
+              </a:spcBef>
+              <a:spcAft>
+                <a:spcPts val="0"/>
+              </a:spcAft>
+              <a:buNone/>
+            </a:lvl7pPr>
+            <a:lvl8pPr marL="0" indent="0">
+              <a:lnSpc>
+                <a:spcPct val="110000"/>
+              </a:lnSpc>
+              <a:spcBef>
+                <a:spcPts val="0"/>
+              </a:spcBef>
+              <a:spcAft>
+                <a:spcPts val="0"/>
+              </a:spcAft>
+              <a:buNone/>
+            </a:lvl8pPr>
+            <a:lvl9pPr marL="0" indent="0">
+              <a:lnSpc>
+                <a:spcPct val="110000"/>
+              </a:lnSpc>
+              <a:spcBef>
+                <a:spcPts val="0"/>
+              </a:spcBef>
+              <a:spcAft>
+                <a:spcPts val="0"/>
+              </a:spcAft>
+              <a:buNone/>
+            </a:lvl9pPr>
+          </a:lstStyle>
+          <a:p xmlns:a="http://schemas.openxmlformats.org/drawingml/2006/main"/>
+        </p:txBody>
+      </p:sp>
+      <p:sp>
+        <p:nvSpPr>
+          <p:cNvPr id="2" name="Body">
+            <a:extLst xmlns:a="http://schemas.openxmlformats.org/drawingml/2006/main">
+              <a:ext uri="{FF2B5EF4-FFF2-40B4-BE49-F238E27FC236}">
+                <a16:creationId xmlns:a16="http://schemas.microsoft.com/office/drawing/2014/main" id="{33791415-04C3-410D-B470-48C6B06B9274}"/>
+              </a:ext>
+            </a:extLst>
+          </p:cNvPr>
+          <p:cNvSpPr>
+            <a:spLocks xmlns:a="http://schemas.openxmlformats.org/drawingml/2006/main" noGrp="1"/>
+          </p:cNvSpPr>
+          <p:nvPr>
+            <p:ph type="body" idx="1"/>
+          </p:nvPr>
+        </p:nvSpPr>
+        <p:spPr>
+          <a:xfrm xmlns:a="http://schemas.openxmlformats.org/drawingml/2006/main">
+            <a:off x="685800" y="1905000"/>
+            <a:ext cx="10820400" cy="4267200"/>
+          </a:xfrm>
+          <a:prstGeom xmlns:a="http://schemas.openxmlformats.org/drawingml/2006/main" prst="rect">
+            <a:avLst/>
+          </a:prstGeom>
+          <a:noFill xmlns:a="http://schemas.openxmlformats.org/drawingml/2006/main"/>
+          <a:ln xmlns:a="http://schemas.openxmlformats.org/drawingml/2006/main">
+            <a:noFill/>
+            <a:prstDash val="solid"/>
+          </a:ln>
+        </p:spPr>
+        <p:txBody>
+          <a:bodyPr xmlns:a="http://schemas.openxmlformats.org/drawingml/2006/main" wrap="square" lIns="0" tIns="0" rIns="0" bIns="0" anchor="t">
+            <a:normAutofit/>
+          </a:bodyPr>
+          <a:lstStyle xmlns:a="http://schemas.openxmlformats.org/drawingml/2006/main">
+            <a:lvl1pPr marL="228600" indent="-228600">
+              <a:lnSpc>
+                <a:spcPct val="110000"/>
+              </a:lnSpc>
+              <a:spcBef>
+                <a:spcPts val="0"/>
+              </a:spcBef>
+              <a:spcAft>
+                <a:spcPts val="1200"/>
+              </a:spcAft>
+              <a:buChar char="•"/>
+            </a:lvl1pPr>
+            <a:lvl2pPr marL="533400" indent="-228600">
+              <a:lnSpc>
+                <a:spcPct val="110000"/>
+              </a:lnSpc>
+              <a:spcBef>
+                <a:spcPts val="0"/>
+              </a:spcBef>
+              <a:spcAft>
+                <a:spcPts val="1200"/>
+              </a:spcAft>
+              <a:buChar char="•"/>
+            </a:lvl2pPr>
+            <a:lvl3pPr marL="838200" indent="-228600">
+              <a:lnSpc>
+                <a:spcPct val="110000"/>
+              </a:lnSpc>
+              <a:spcBef>
+                <a:spcPts val="0"/>
+              </a:spcBef>
+              <a:spcAft>
+                <a:spcPts val="1200"/>
+              </a:spcAft>
+              <a:buChar char="•"/>
+            </a:lvl3pPr>
+            <a:lvl4pPr marL="1143000" indent="-228600">
+              <a:lnSpc>
+                <a:spcPct val="110000"/>
+              </a:lnSpc>
+              <a:spcBef>
+                <a:spcPts val="0"/>
+              </a:spcBef>
+              <a:spcAft>
+                <a:spcPts val="1200"/>
+              </a:spcAft>
+              <a:buChar char="•"/>
+            </a:lvl4pPr>
+            <a:lvl5pPr marL="1447800" indent="-228600">
+              <a:lnSpc>
+                <a:spcPct val="110000"/>
+              </a:lnSpc>
+              <a:spcBef>
+                <a:spcPts val="0"/>
+              </a:spcBef>
+              <a:spcAft>
+                <a:spcPts val="1200"/>
+              </a:spcAft>
+              <a:buChar char="•"/>
+            </a:lvl5pPr>
+            <a:lvl6pPr marL="1752600" indent="-228600">
+              <a:lnSpc>
+                <a:spcPct val="110000"/>
+              </a:lnSpc>
+              <a:spcBef>
+                <a:spcPts val="0"/>
+              </a:spcBef>
+              <a:spcAft>
+                <a:spcPts val="1200"/>
+              </a:spcAft>
+              <a:buChar char="•"/>
+            </a:lvl6pPr>
+            <a:lvl7pPr marL="2057400" indent="-228600">
+              <a:lnSpc>
+                <a:spcPct val="110000"/>
+              </a:lnSpc>
+              <a:spcBef>
+                <a:spcPts val="0"/>
+              </a:spcBef>
+              <a:spcAft>
+                <a:spcPts val="1200"/>
+              </a:spcAft>
+              <a:buChar char="•"/>
+            </a:lvl7pPr>
+            <a:lvl8pPr marL="2362200" indent="-228600">
+              <a:lnSpc>
+                <a:spcPct val="110000"/>
+              </a:lnSpc>
+              <a:spcBef>
+                <a:spcPts val="0"/>
+              </a:spcBef>
+              <a:spcAft>
+                <a:spcPts val="1200"/>
+              </a:spcAft>
+              <a:buChar char="•"/>
+            </a:lvl8pPr>
+            <a:lvl9pPr marL="2667000" indent="-228600">
+              <a:lnSpc>
+                <a:spcPct val="110000"/>
+              </a:lnSpc>
+              <a:spcBef>
+                <a:spcPts val="0"/>
+              </a:spcBef>
+              <a:spcAft>
+                <a:spcPts val="1200"/>
+              </a:spcAft>
+              <a:buChar char="•"/>
+            </a:lvl9pPr>
+          </a:lstStyle>
+          <a:p xmlns:a="http://schemas.openxmlformats.org/drawingml/2006/main"/>
+        </p:txBody>
+      </p:sp>
+    </p:spTree>
+  </p:cSld>
+</p:sldLayout>
+</file>
+
+<file path=ppt/slideLayouts/slideLayout4.xml><?xml version="1.0" encoding="utf-8"?>
+<p:sldLayout xmlns:p="http://schemas.openxmlformats.org/presentationml/2006/main">
+  <p:cSld name="Title and Two Column">
+    <p:spTree>
+      <p:nvGrpSpPr>
+        <p:cNvPr id="1" name=""/>
+        <p:cNvGrpSpPr/>
+        <p:nvPr/>
+      </p:nvGrpSpPr>
+      <p:grpSpPr>
+        <a:xfrm xmlns:a="http://schemas.openxmlformats.org/drawingml/2006/main"/>
+      </p:grpSpPr>
+      <p:sp>
+        <p:nvSpPr>
+          <p:cNvPr id="4" name="Title">
+            <a:extLst xmlns:a="http://schemas.openxmlformats.org/drawingml/2006/main">
+              <a:ext uri="{FF2B5EF4-FFF2-40B4-BE49-F238E27FC236}">
+                <a16:creationId xmlns:a16="http://schemas.microsoft.com/office/drawing/2014/main" id="{D1F5AA87-662D-4164-9DAA-C6557ED23851}"/>
+              </a:ext>
+            </a:extLst>
+          </p:cNvPr>
+          <p:cNvSpPr>
+            <a:spLocks xmlns:a="http://schemas.openxmlformats.org/drawingml/2006/main" noGrp="1"/>
+          </p:cNvSpPr>
+          <p:nvPr>
+            <p:ph type="title" idx="0"/>
+          </p:nvPr>
+        </p:nvSpPr>
+        <p:spPr>
+          <a:xfrm xmlns:a="http://schemas.openxmlformats.org/drawingml/2006/main">
+            <a:off x="685800" y="533400"/>
+            <a:ext cx="10820400" cy="838200"/>
+          </a:xfrm>
+          <a:prstGeom xmlns:a="http://schemas.openxmlformats.org/drawingml/2006/main" prst="rect">
+            <a:avLst/>
+          </a:prstGeom>
+          <a:noFill xmlns:a="http://schemas.openxmlformats.org/drawingml/2006/main"/>
+          <a:ln xmlns:a="http://schemas.openxmlformats.org/drawingml/2006/main">
+            <a:noFill/>
+            <a:prstDash val="solid"/>
+          </a:ln>
+        </p:spPr>
+        <p:txBody>
+          <a:bodyPr xmlns:a="http://schemas.openxmlformats.org/drawingml/2006/main" wrap="square" lIns="0" tIns="0" rIns="0" bIns="0" anchor="t">
+            <a:normAutofit/>
+          </a:bodyPr>
+          <a:lstStyle xmlns:a="http://schemas.openxmlformats.org/drawingml/2006/main">
+            <a:lvl1pPr marL="0" indent="0">
+              <a:lnSpc>
+                <a:spcPct val="110000"/>
+              </a:lnSpc>
+              <a:spcBef>
+                <a:spcPts val="0"/>
+              </a:spcBef>
+              <a:spcAft>
+                <a:spcPts val="0"/>
+              </a:spcAft>
+              <a:buNone/>
+            </a:lvl1pPr>
+            <a:lvl2pPr marL="0" indent="0">
+              <a:lnSpc>
+                <a:spcPct val="110000"/>
+              </a:lnSpc>
+              <a:spcBef>
+                <a:spcPts val="0"/>
+              </a:spcBef>
+              <a:spcAft>
+                <a:spcPts val="0"/>
+              </a:spcAft>
+              <a:buNone/>
+            </a:lvl2pPr>
+            <a:lvl3pPr marL="0" indent="0">
+              <a:lnSpc>
+                <a:spcPct val="110000"/>
+              </a:lnSpc>
+              <a:spcBef>
+                <a:spcPts val="0"/>
+              </a:spcBef>
+              <a:spcAft>
+                <a:spcPts val="0"/>
+              </a:spcAft>
+              <a:buNone/>
+            </a:lvl3pPr>
+            <a:lvl4pPr marL="0" indent="0">
+              <a:lnSpc>
+                <a:spcPct val="110000"/>
+              </a:lnSpc>
+              <a:spcBef>
+                <a:spcPts val="0"/>
+              </a:spcBef>
+              <a:spcAft>
+                <a:spcPts val="0"/>
+              </a:spcAft>
+              <a:buNone/>
+            </a:lvl4pPr>
+            <a:lvl5pPr marL="0" indent="0">
+              <a:lnSpc>
+                <a:spcPct val="110000"/>
+              </a:lnSpc>
+              <a:spcBef>
+                <a:spcPts val="0"/>
+              </a:spcBef>
+              <a:spcAft>
+                <a:spcPts val="0"/>
+              </a:spcAft>
+              <a:buNone/>
+            </a:lvl5pPr>
+            <a:lvl6pPr marL="0" indent="0">
+              <a:lnSpc>
+                <a:spcPct val="110000"/>
+              </a:lnSpc>
+              <a:spcBef>
+                <a:spcPts val="0"/>
+              </a:spcBef>
+              <a:spcAft>
+                <a:spcPts val="0"/>
+              </a:spcAft>
+              <a:buNone/>
+            </a:lvl6pPr>
+            <a:lvl7pPr marL="0" indent="0">
+              <a:lnSpc>
+                <a:spcPct val="110000"/>
+              </a:lnSpc>
+              <a:spcBef>
+                <a:spcPts val="0"/>
+              </a:spcBef>
+              <a:spcAft>
+                <a:spcPts val="0"/>
+              </a:spcAft>
+              <a:buNone/>
+            </a:lvl7pPr>
+            <a:lvl8pPr marL="0" indent="0">
+              <a:lnSpc>
+                <a:spcPct val="110000"/>
+              </a:lnSpc>
+              <a:spcBef>
+                <a:spcPts val="0"/>
+              </a:spcBef>
+              <a:spcAft>
+                <a:spcPts val="0"/>
+              </a:spcAft>
+              <a:buNone/>
+            </a:lvl8pPr>
+            <a:lvl9pPr marL="0" indent="0">
+              <a:lnSpc>
+                <a:spcPct val="110000"/>
+              </a:lnSpc>
+              <a:spcBef>
+                <a:spcPts val="0"/>
+              </a:spcBef>
+              <a:spcAft>
+                <a:spcPts val="0"/>
+              </a:spcAft>
+              <a:buNone/>
+            </a:lvl9pPr>
+          </a:lstStyle>
+          <a:p xmlns:a="http://schemas.openxmlformats.org/drawingml/2006/main"/>
+        </p:txBody>
+      </p:sp>
+      <p:sp>
+        <p:nvSpPr>
+          <p:cNvPr id="2" name="Left column">
+            <a:extLst xmlns:a="http://schemas.openxmlformats.org/drawingml/2006/main">
+              <a:ext uri="{FF2B5EF4-FFF2-40B4-BE49-F238E27FC236}">
+                <a16:creationId xmlns:a16="http://schemas.microsoft.com/office/drawing/2014/main" id="{F74F0650-0783-4268-8DE4-BC5384DC2CC3}"/>
+              </a:ext>
+            </a:extLst>
+          </p:cNvPr>
+          <p:cNvSpPr>
+            <a:spLocks xmlns:a="http://schemas.openxmlformats.org/drawingml/2006/main" noGrp="1"/>
+          </p:cNvSpPr>
+          <p:nvPr>
+            <p:ph type="body" idx="1"/>
+          </p:nvPr>
+        </p:nvSpPr>
+        <p:spPr>
+          <a:xfrm xmlns:a="http://schemas.openxmlformats.org/drawingml/2006/main">
+            <a:off x="685800" y="1905000"/>
+            <a:ext cx="5029200" cy="4267200"/>
+          </a:xfrm>
+          <a:prstGeom xmlns:a="http://schemas.openxmlformats.org/drawingml/2006/main" prst="rect">
+            <a:avLst/>
+          </a:prstGeom>
+          <a:noFill xmlns:a="http://schemas.openxmlformats.org/drawingml/2006/main"/>
+          <a:ln xmlns:a="http://schemas.openxmlformats.org/drawingml/2006/main">
+            <a:noFill/>
+            <a:prstDash val="solid"/>
+          </a:ln>
+        </p:spPr>
+        <p:txBody>
+          <a:bodyPr xmlns:a="http://schemas.openxmlformats.org/drawingml/2006/main" wrap="square" lIns="0" tIns="0" rIns="0" bIns="0" anchor="t">
+            <a:normAutofit/>
+          </a:bodyPr>
+          <a:lstStyle xmlns:a="http://schemas.openxmlformats.org/drawingml/2006/main">
+            <a:lvl1pPr marL="228600" indent="-228600">
+              <a:lnSpc>
+                <a:spcPct val="110000"/>
+              </a:lnSpc>
+              <a:spcBef>
+                <a:spcPts val="0"/>
+              </a:spcBef>
+              <a:spcAft>
+                <a:spcPts val="1200"/>
+              </a:spcAft>
+              <a:buChar char="•"/>
+            </a:lvl1pPr>
+            <a:lvl2pPr marL="533400" indent="-228600">
+              <a:lnSpc>
+                <a:spcPct val="110000"/>
+              </a:lnSpc>
+              <a:spcBef>
+                <a:spcPts val="0"/>
+              </a:spcBef>
+              <a:spcAft>
+                <a:spcPts val="1200"/>
+              </a:spcAft>
+              <a:buChar char="•"/>
+            </a:lvl2pPr>
+            <a:lvl3pPr marL="838200" indent="-228600">
+              <a:lnSpc>
+                <a:spcPct val="110000"/>
+              </a:lnSpc>
+              <a:spcBef>
+                <a:spcPts val="0"/>
+              </a:spcBef>
+              <a:spcAft>
+                <a:spcPts val="1200"/>
+              </a:spcAft>
+              <a:buChar char="•"/>
+            </a:lvl3pPr>
+            <a:lvl4pPr marL="1143000" indent="-228600">
+              <a:lnSpc>
+                <a:spcPct val="110000"/>
+              </a:lnSpc>
+              <a:spcBef>
+                <a:spcPts val="0"/>
+              </a:spcBef>
+              <a:spcAft>
+                <a:spcPts val="1200"/>
+              </a:spcAft>
+              <a:buChar char="•"/>
+            </a:lvl4pPr>
+            <a:lvl5pPr marL="1447800" indent="-228600">
+              <a:lnSpc>
+                <a:spcPct val="110000"/>
+              </a:lnSpc>
+              <a:spcBef>
+                <a:spcPts val="0"/>
+              </a:spcBef>
+              <a:spcAft>
+                <a:spcPts val="1200"/>
+              </a:spcAft>
+              <a:buChar char="•"/>
+            </a:lvl5pPr>
+            <a:lvl6pPr marL="1752600" indent="-228600">
+              <a:lnSpc>
+                <a:spcPct val="110000"/>
+              </a:lnSpc>
+              <a:spcBef>
+                <a:spcPts val="0"/>
+              </a:spcBef>
+              <a:spcAft>
+                <a:spcPts val="1200"/>
+              </a:spcAft>
+              <a:buChar char="•"/>
+            </a:lvl6pPr>
+            <a:lvl7pPr marL="2057400" indent="-228600">
+              <a:lnSpc>
+                <a:spcPct val="110000"/>
+              </a:lnSpc>
+              <a:spcBef>
+                <a:spcPts val="0"/>
+              </a:spcBef>
+              <a:spcAft>
+                <a:spcPts val="1200"/>
+              </a:spcAft>
+              <a:buChar char="•"/>
+            </a:lvl7pPr>
+            <a:lvl8pPr marL="2362200" indent="-228600">
+              <a:lnSpc>
+                <a:spcPct val="110000"/>
+              </a:lnSpc>
+              <a:spcBef>
+                <a:spcPts val="0"/>
+              </a:spcBef>
+              <a:spcAft>
+                <a:spcPts val="1200"/>
+              </a:spcAft>
+              <a:buChar char="•"/>
+            </a:lvl8pPr>
+            <a:lvl9pPr marL="2667000" indent="-228600">
+              <a:lnSpc>
+                <a:spcPct val="110000"/>
+              </a:lnSpc>
+              <a:spcBef>
+                <a:spcPts val="0"/>
+              </a:spcBef>
+              <a:spcAft>
+                <a:spcPts val="1200"/>
+              </a:spcAft>
+              <a:buChar char="•"/>
+            </a:lvl9pPr>
+          </a:lstStyle>
+          <a:p xmlns:a="http://schemas.openxmlformats.org/drawingml/2006/main"/>
+        </p:txBody>
+      </p:sp>
+      <p:sp>
+        <p:nvSpPr>
+          <p:cNvPr id="3" name="Right column">
+            <a:extLst xmlns:a="http://schemas.openxmlformats.org/drawingml/2006/main">
+              <a:ext uri="{FF2B5EF4-FFF2-40B4-BE49-F238E27FC236}">
+                <a16:creationId xmlns:a16="http://schemas.microsoft.com/office/drawing/2014/main" id="{D3AD48B4-6356-4CBB-83B5-A6FD5542744B}"/>
+              </a:ext>
+            </a:extLst>
+          </p:cNvPr>
+          <p:cNvSpPr>
+            <a:spLocks xmlns:a="http://schemas.openxmlformats.org/drawingml/2006/main" noGrp="1"/>
+          </p:cNvSpPr>
+          <p:nvPr>
+            <p:ph type="body" idx="2"/>
+          </p:nvPr>
+        </p:nvSpPr>
+        <p:spPr>
+          <a:xfrm xmlns:a="http://schemas.openxmlformats.org/drawingml/2006/main">
+            <a:off x="6477000" y="1905000"/>
+            <a:ext cx="5029200" cy="4267200"/>
+          </a:xfrm>
+          <a:prstGeom xmlns:a="http://schemas.openxmlformats.org/drawingml/2006/main" prst="rect">
+            <a:avLst/>
+          </a:prstGeom>
+          <a:noFill xmlns:a="http://schemas.openxmlformats.org/drawingml/2006/main"/>
+          <a:ln xmlns:a="http://schemas.openxmlformats.org/drawingml/2006/main">
+            <a:noFill/>
+            <a:prstDash val="solid"/>
+          </a:ln>
+        </p:spPr>
+        <p:txBody>
+          <a:bodyPr xmlns:a="http://schemas.openxmlformats.org/drawingml/2006/main" wrap="square" lIns="0" tIns="0" rIns="0" bIns="0" anchor="t">
+            <a:normAutofit/>
+          </a:bodyPr>
+          <a:lstStyle xmlns:a="http://schemas.openxmlformats.org/drawingml/2006/main">
+            <a:lvl1pPr marL="228600" indent="-228600">
+              <a:lnSpc>
+                <a:spcPct val="110000"/>
+              </a:lnSpc>
+              <a:spcBef>
+                <a:spcPts val="0"/>
+              </a:spcBef>
+              <a:spcAft>
+                <a:spcPts val="1200"/>
+              </a:spcAft>
+              <a:buChar char="•"/>
+            </a:lvl1pPr>
+            <a:lvl2pPr marL="533400" indent="-228600">
+              <a:lnSpc>
+                <a:spcPct val="110000"/>
+              </a:lnSpc>
+              <a:spcBef>
+                <a:spcPts val="0"/>
+              </a:spcBef>
+              <a:spcAft>
+                <a:spcPts val="1200"/>
+              </a:spcAft>
+              <a:buChar char="•"/>
+            </a:lvl2pPr>
+            <a:lvl3pPr marL="838200" indent="-228600">
+              <a:lnSpc>
+                <a:spcPct val="110000"/>
+              </a:lnSpc>
+              <a:spcBef>
+                <a:spcPts val="0"/>
+              </a:spcBef>
+              <a:spcAft>
+                <a:spcPts val="1200"/>
+              </a:spcAft>
+              <a:buChar char="•"/>
+            </a:lvl3pPr>
+            <a:lvl4pPr marL="1143000" indent="-228600">
+              <a:lnSpc>
+                <a:spcPct val="110000"/>
+              </a:lnSpc>
+              <a:spcBef>
+                <a:spcPts val="0"/>
+              </a:spcBef>
+              <a:spcAft>
+                <a:spcPts val="1200"/>
+              </a:spcAft>
+              <a:buChar char="•"/>
+            </a:lvl4pPr>
+            <a:lvl5pPr marL="1447800" indent="-228600">
+              <a:lnSpc>
+                <a:spcPct val="110000"/>
+              </a:lnSpc>
+              <a:spcBef>
+                <a:spcPts val="0"/>
+              </a:spcBef>
+              <a:spcAft>
+                <a:spcPts val="1200"/>
+              </a:spcAft>
+              <a:buChar char="•"/>
+            </a:lvl5pPr>
+            <a:lvl6pPr marL="1752600" indent="-228600">
+              <a:lnSpc>
+                <a:spcPct val="110000"/>
+              </a:lnSpc>
+              <a:spcBef>
+                <a:spcPts val="0"/>
+              </a:spcBef>
+              <a:spcAft>
+                <a:spcPts val="1200"/>
+              </a:spcAft>
+              <a:buChar char="•"/>
+            </a:lvl6pPr>
+            <a:lvl7pPr marL="2057400" indent="-228600">
+              <a:lnSpc>
+                <a:spcPct val="110000"/>
+              </a:lnSpc>
+              <a:spcBef>
+                <a:spcPts val="0"/>
+              </a:spcBef>
+              <a:spcAft>
+                <a:spcPts val="1200"/>
+              </a:spcAft>
+              <a:buChar char="•"/>
+            </a:lvl7pPr>
+            <a:lvl8pPr marL="2362200" indent="-228600">
+              <a:lnSpc>
+                <a:spcPct val="110000"/>
+              </a:lnSpc>
+              <a:spcBef>
+                <a:spcPts val="0"/>
+              </a:spcBef>
+              <a:spcAft>
+                <a:spcPts val="1200"/>
+              </a:spcAft>
+              <a:buChar char="•"/>
+            </a:lvl8pPr>
+            <a:lvl9pPr marL="2667000" indent="-228600">
+              <a:lnSpc>
+                <a:spcPct val="110000"/>
+              </a:lnSpc>
+              <a:spcBef>
+                <a:spcPts val="0"/>
+              </a:spcBef>
+              <a:spcAft>
+                <a:spcPts val="1200"/>
+              </a:spcAft>
+              <a:buChar char="•"/>
+            </a:lvl9pPr>
+          </a:lstStyle>
+          <a:p xmlns:a="http://schemas.openxmlformats.org/drawingml/2006/main"/>
+        </p:txBody>
+      </p:sp>
+    </p:spTree>
+  </p:cSld>
+</p:sldLayout>
+</file>
+
+<file path=ppt/slideLayouts/slideLayout5.xml><?xml version="1.0" encoding="utf-8"?>
+<p:sldLayout xmlns:p="http://schemas.openxmlformats.org/presentationml/2006/main">
+  <p:cSld name="Title and One Column">
+    <p:spTree>
+      <p:nvGrpSpPr>
+        <p:cNvPr id="1" name=""/>
+        <p:cNvGrpSpPr/>
+        <p:nvPr/>
+      </p:nvGrpSpPr>
+      <p:grpSpPr>
+        <a:xfrm xmlns:a="http://schemas.openxmlformats.org/drawingml/2006/main"/>
+      </p:grpSpPr>
+      <p:sp>
+        <p:nvSpPr>
+          <p:cNvPr id="3" name="Title">
+            <a:extLst xmlns:a="http://schemas.openxmlformats.org/drawingml/2006/main">
+              <a:ext uri="{FF2B5EF4-FFF2-40B4-BE49-F238E27FC236}">
+                <a16:creationId xmlns:a16="http://schemas.microsoft.com/office/drawing/2014/main" id="{0F75E962-D248-48B4-BD33-D0FFCAEC694F}"/>
+              </a:ext>
+            </a:extLst>
+          </p:cNvPr>
+          <p:cNvSpPr>
+            <a:spLocks xmlns:a="http://schemas.openxmlformats.org/drawingml/2006/main" noGrp="1"/>
+          </p:cNvSpPr>
+          <p:nvPr>
+            <p:ph type="title" idx="0"/>
+          </p:nvPr>
+        </p:nvSpPr>
+        <p:spPr>
+          <a:xfrm xmlns:a="http://schemas.openxmlformats.org/drawingml/2006/main">
+            <a:off x="685800" y="533400"/>
+            <a:ext cx="10820400" cy="838200"/>
+          </a:xfrm>
+          <a:prstGeom xmlns:a="http://schemas.openxmlformats.org/drawingml/2006/main" prst="rect">
+            <a:avLst/>
+          </a:prstGeom>
+          <a:noFill xmlns:a="http://schemas.openxmlformats.org/drawingml/2006/main"/>
+          <a:ln xmlns:a="http://schemas.openxmlformats.org/drawingml/2006/main">
+            <a:noFill/>
+            <a:prstDash val="solid"/>
+          </a:ln>
+        </p:spPr>
+        <p:txBody>
+          <a:bodyPr xmlns:a="http://schemas.openxmlformats.org/drawingml/2006/main" wrap="square" lIns="0" tIns="0" rIns="0" bIns="0" anchor="t">
+            <a:normAutofit/>
+          </a:bodyPr>
+          <a:lstStyle xmlns:a="http://schemas.openxmlformats.org/drawingml/2006/main">
+            <a:lvl1pPr marL="0" indent="0">
+              <a:lnSpc>
+                <a:spcPct val="110000"/>
+              </a:lnSpc>
+              <a:spcBef>
+                <a:spcPts val="0"/>
+              </a:spcBef>
+              <a:spcAft>
+                <a:spcPts val="0"/>
+              </a:spcAft>
+              <a:buNone/>
+            </a:lvl1pPr>
+            <a:lvl2pPr marL="0" indent="0">
+              <a:lnSpc>
+                <a:spcPct val="110000"/>
+              </a:lnSpc>
+              <a:spcBef>
+                <a:spcPts val="0"/>
+              </a:spcBef>
+              <a:spcAft>
+                <a:spcPts val="0"/>
+              </a:spcAft>
+              <a:buNone/>
+            </a:lvl2pPr>
+            <a:lvl3pPr marL="0" indent="0">
+              <a:lnSpc>
+                <a:spcPct val="110000"/>
+              </a:lnSpc>
+              <a:spcBef>
+                <a:spcPts val="0"/>
+              </a:spcBef>
+              <a:spcAft>
+                <a:spcPts val="0"/>
+              </a:spcAft>
+              <a:buNone/>
+            </a:lvl3pPr>
+            <a:lvl4pPr marL="0" indent="0">
+              <a:lnSpc>
+                <a:spcPct val="110000"/>
+              </a:lnSpc>
+              <a:spcBef>
+                <a:spcPts val="0"/>
+              </a:spcBef>
+              <a:spcAft>
+                <a:spcPts val="0"/>
+              </a:spcAft>
+              <a:buNone/>
+            </a:lvl4pPr>
+            <a:lvl5pPr marL="0" indent="0">
+              <a:lnSpc>
+                <a:spcPct val="110000"/>
+              </a:lnSpc>
+              <a:spcBef>
+                <a:spcPts val="0"/>
+              </a:spcBef>
+              <a:spcAft>
+                <a:spcPts val="0"/>
+              </a:spcAft>
+              <a:buNone/>
+            </a:lvl5pPr>
+            <a:lvl6pPr marL="0" indent="0">
+              <a:lnSpc>
+                <a:spcPct val="110000"/>
+              </a:lnSpc>
+              <a:spcBef>
+                <a:spcPts val="0"/>
+              </a:spcBef>
+              <a:spcAft>
+                <a:spcPts val="0"/>
+              </a:spcAft>
+              <a:buNone/>
+            </a:lvl6pPr>
+            <a:lvl7pPr marL="0" indent="0">
+              <a:lnSpc>
+                <a:spcPct val="110000"/>
+              </a:lnSpc>
+              <a:spcBef>
+                <a:spcPts val="0"/>
+              </a:spcBef>
+              <a:spcAft>
+                <a:spcPts val="0"/>
+              </a:spcAft>
+              <a:buNone/>
+            </a:lvl7pPr>
+            <a:lvl8pPr marL="0" indent="0">
+              <a:lnSpc>
+                <a:spcPct val="110000"/>
+              </a:lnSpc>
+              <a:spcBef>
+                <a:spcPts val="0"/>
+              </a:spcBef>
+              <a:spcAft>
+                <a:spcPts val="0"/>
+              </a:spcAft>
+              <a:buNone/>
+            </a:lvl8pPr>
+            <a:lvl9pPr marL="0" indent="0">
+              <a:lnSpc>
+                <a:spcPct val="110000"/>
+              </a:lnSpc>
+              <a:spcBef>
+                <a:spcPts val="0"/>
+              </a:spcBef>
+              <a:spcAft>
+                <a:spcPts val="0"/>
+              </a:spcAft>
+              <a:buNone/>
+            </a:lvl9pPr>
+          </a:lstStyle>
+          <a:p xmlns:a="http://schemas.openxmlformats.org/drawingml/2006/main"/>
+        </p:txBody>
+      </p:sp>
+      <p:sp>
+        <p:nvSpPr>
+          <p:cNvPr id="2" name="Left column">
+            <a:extLst xmlns:a="http://schemas.openxmlformats.org/drawingml/2006/main">
+              <a:ext uri="{FF2B5EF4-FFF2-40B4-BE49-F238E27FC236}">
+                <a16:creationId xmlns:a16="http://schemas.microsoft.com/office/drawing/2014/main" id="{8FA7E237-EBEF-44D6-AF9D-5A74692725D0}"/>
+              </a:ext>
+            </a:extLst>
+          </p:cNvPr>
+          <p:cNvSpPr>
+            <a:spLocks xmlns:a="http://schemas.openxmlformats.org/drawingml/2006/main" noGrp="1"/>
+          </p:cNvSpPr>
+          <p:nvPr>
+            <p:ph type="body" idx="1"/>
+          </p:nvPr>
+        </p:nvSpPr>
+        <p:spPr>
+          <a:xfrm xmlns:a="http://schemas.openxmlformats.org/drawingml/2006/main">
+            <a:off x="685800" y="1905000"/>
+            <a:ext cx="5029200" cy="4267200"/>
+          </a:xfrm>
+          <a:prstGeom xmlns:a="http://schemas.openxmlformats.org/drawingml/2006/main" prst="rect">
+            <a:avLst/>
+          </a:prstGeom>
+          <a:noFill xmlns:a="http://schemas.openxmlformats.org/drawingml/2006/main"/>
+          <a:ln xmlns:a="http://schemas.openxmlformats.org/drawingml/2006/main">
+            <a:noFill/>
+            <a:prstDash val="solid"/>
+          </a:ln>
+        </p:spPr>
+        <p:txBody>
+          <a:bodyPr xmlns:a="http://schemas.openxmlformats.org/drawingml/2006/main" wrap="square" lIns="0" tIns="0" rIns="0" bIns="0" anchor="t">
+            <a:normAutofit/>
+          </a:bodyPr>
+          <a:lstStyle xmlns:a="http://schemas.openxmlformats.org/drawingml/2006/main">
+            <a:lvl1pPr marL="228600" indent="-228600">
+              <a:lnSpc>
+                <a:spcPct val="110000"/>
+              </a:lnSpc>
+              <a:spcBef>
+                <a:spcPts val="0"/>
+              </a:spcBef>
+              <a:spcAft>
+                <a:spcPts val="1200"/>
+              </a:spcAft>
+              <a:buChar char="•"/>
+            </a:lvl1pPr>
+            <a:lvl2pPr marL="533400" indent="-228600">
+              <a:lnSpc>
+                <a:spcPct val="110000"/>
+              </a:lnSpc>
+              <a:spcBef>
+                <a:spcPts val="0"/>
+              </a:spcBef>
+              <a:spcAft>
+                <a:spcPts val="1200"/>
+              </a:spcAft>
+              <a:buChar char="•"/>
+            </a:lvl2pPr>
+            <a:lvl3pPr marL="838200" indent="-228600">
+              <a:lnSpc>
+                <a:spcPct val="110000"/>
+              </a:lnSpc>
+              <a:spcBef>
+                <a:spcPts val="0"/>
+              </a:spcBef>
+              <a:spcAft>
+                <a:spcPts val="1200"/>
+              </a:spcAft>
+              <a:buChar char="•"/>
+            </a:lvl3pPr>
+            <a:lvl4pPr marL="1143000" indent="-228600">
+              <a:lnSpc>
+                <a:spcPct val="110000"/>
+              </a:lnSpc>
+              <a:spcBef>
+                <a:spcPts val="0"/>
+              </a:spcBef>
+              <a:spcAft>
+                <a:spcPts val="1200"/>
+              </a:spcAft>
+              <a:buChar char="•"/>
+            </a:lvl4pPr>
+            <a:lvl5pPr marL="1447800" indent="-228600">
+              <a:lnSpc>
+                <a:spcPct val="110000"/>
+              </a:lnSpc>
+              <a:spcBef>
+                <a:spcPts val="0"/>
+              </a:spcBef>
+              <a:spcAft>
+                <a:spcPts val="1200"/>
+              </a:spcAft>
+              <a:buChar char="•"/>
+            </a:lvl5pPr>
+            <a:lvl6pPr marL="1752600" indent="-228600">
+              <a:lnSpc>
+                <a:spcPct val="110000"/>
+              </a:lnSpc>
+              <a:spcBef>
+                <a:spcPts val="0"/>
+              </a:spcBef>
+              <a:spcAft>
+                <a:spcPts val="1200"/>
+              </a:spcAft>
+              <a:buChar char="•"/>
+            </a:lvl6pPr>
+            <a:lvl7pPr marL="2057400" indent="-228600">
+              <a:lnSpc>
+                <a:spcPct val="110000"/>
+              </a:lnSpc>
+              <a:spcBef>
+                <a:spcPts val="0"/>
+              </a:spcBef>
+              <a:spcAft>
+                <a:spcPts val="1200"/>
+              </a:spcAft>
+              <a:buChar char="•"/>
+            </a:lvl7pPr>
+            <a:lvl8pPr marL="2362200" indent="-228600">
+              <a:lnSpc>
+                <a:spcPct val="110000"/>
+              </a:lnSpc>
+              <a:spcBef>
+                <a:spcPts val="0"/>
+              </a:spcBef>
+              <a:spcAft>
+                <a:spcPts val="1200"/>
+              </a:spcAft>
+              <a:buChar char="•"/>
+            </a:lvl8pPr>
+            <a:lvl9pPr marL="2667000" indent="-228600">
+              <a:lnSpc>
+                <a:spcPct val="110000"/>
+              </a:lnSpc>
+              <a:spcBef>
+                <a:spcPts val="0"/>
+              </a:spcBef>
+              <a:spcAft>
+                <a:spcPts val="1200"/>
+              </a:spcAft>
+              <a:buChar char="•"/>
+            </a:lvl9pPr>
+          </a:lstStyle>
+          <a:p xmlns:a="http://schemas.openxmlformats.org/drawingml/2006/main"/>
+        </p:txBody>
+      </p:sp>
+    </p:spTree>
+  </p:cSld>
+</p:sldLayout>
+</file>
+
+<file path=ppt/slideLayouts/slideLayout6.xml><?xml version="1.0" encoding="utf-8"?>
+<p:sldLayout xmlns:p="http://schemas.openxmlformats.org/presentationml/2006/main" type="blank">
+  <p:cSld name="Blank">
     <p:spTree>
       <p:nvGrpSpPr>
         <p:cNvPr id="1" name=""/>
@@ -1012,7 +2567,12 @@
   </p:cSld>
   <p:clrMap bg1="lt1" tx1="dk1" bg2="lt2" tx2="dk2" accent1="accent1" accent2="accent2" accent3="accent3" accent4="accent4" accent5="accent5" accent6="accent6" hlink="hlink" folHlink="folHlink"/>
   <p:sldLayoutIdLst>
-    <p:sldLayoutId xmlns:r="http://schemas.openxmlformats.org/officeDocument/2006/relationships" id="2147483649" r:id="R600d026025c44b42"/>
+    <p:sldLayoutId xmlns:r="http://schemas.openxmlformats.org/officeDocument/2006/relationships" id="2147483649" r:id="R5dd819a1ce8e43be"/>
+    <p:sldLayoutId xmlns:r="http://schemas.openxmlformats.org/officeDocument/2006/relationships" id="2147483650" r:id="Re4ea0939508e4bf5"/>
+    <p:sldLayoutId xmlns:r="http://schemas.openxmlformats.org/officeDocument/2006/relationships" id="2147483651" r:id="Rb728a930225b4dd7"/>
+    <p:sldLayoutId xmlns:r="http://schemas.openxmlformats.org/officeDocument/2006/relationships" id="2147483652" r:id="Rdf4e702aa179434a"/>
+    <p:sldLayoutId xmlns:r="http://schemas.openxmlformats.org/officeDocument/2006/relationships" id="2147483653" r:id="R37f5c551df8c44bd"/>
+    <p:sldLayoutId xmlns:r="http://schemas.openxmlformats.org/officeDocument/2006/relationships" id="2147483654" r:id="R20851832951a4f9b"/>
   </p:sldLayoutIdLst>
   <p:txStyles>
     <p:titleStyle>
@@ -1567,7 +3127,7 @@
           <p:nvPr/>
         </p:nvPicPr>
         <p:blipFill>
-          <a:blip xmlns:r="http://schemas.openxmlformats.org/officeDocument/2006/relationships" xmlns:a="http://schemas.openxmlformats.org/drawingml/2006/main" r:embed="Rd491738052644bf3"/>
+          <a:blip xmlns:r="http://schemas.openxmlformats.org/officeDocument/2006/relationships" xmlns:a="http://schemas.openxmlformats.org/drawingml/2006/main" r:embed="R77132a6933024175"/>
           <a:srcRect xmlns:a="http://schemas.openxmlformats.org/drawingml/2006/main" l="0" t="27" r="0" b="27"/>
           <a:stretch xmlns:a="http://schemas.openxmlformats.org/drawingml/2006/main">
             <a:fillRect l="0" t="0" r="0" b="0"/>
@@ -1588,7 +3148,7 @@
           <p:cNvPr id="2" name="">
             <a:extLst xmlns:a="http://schemas.openxmlformats.org/drawingml/2006/main">
               <a:ext uri="{FF2B5EF4-FFF2-40B4-BE49-F238E27FC236}">
-                <a16:creationId xmlns:a16="http://schemas.microsoft.com/office/drawing/2014/main" id="{16D2DEC1-2974-4153-95ED-757B394B9188}"/>
+                <a16:creationId xmlns:a16="http://schemas.microsoft.com/office/drawing/2014/main" id="{9F590DAC-DBF6-4F53-A1C0-78E39FA45CEF}"/>
               </a:ext>
             </a:extLst>
           </p:cNvPr>
@@ -1645,7 +3205,7 @@
           <p:cNvPr id="3" name="">
             <a:extLst xmlns:a="http://schemas.openxmlformats.org/drawingml/2006/main">
               <a:ext uri="{FF2B5EF4-FFF2-40B4-BE49-F238E27FC236}">
-                <a16:creationId xmlns:a16="http://schemas.microsoft.com/office/drawing/2014/main" id="{3A109411-6C26-4B71-8957-4FC93F45FCA8}"/>
+                <a16:creationId xmlns:a16="http://schemas.microsoft.com/office/drawing/2014/main" id="{64A708A1-9405-40B6-A7A2-2F8EA6695867}"/>
               </a:ext>
             </a:extLst>
           </p:cNvPr>
@@ -1702,7 +3262,7 @@
           <p:cNvPr id="4" name="">
             <a:extLst xmlns:a="http://schemas.openxmlformats.org/drawingml/2006/main">
               <a:ext uri="{FF2B5EF4-FFF2-40B4-BE49-F238E27FC236}">
-                <a16:creationId xmlns:a16="http://schemas.microsoft.com/office/drawing/2014/main" id="{B32C6BB8-E748-4663-945D-48A6EA8084C7}"/>
+                <a16:creationId xmlns:a16="http://schemas.microsoft.com/office/drawing/2014/main" id="{DDDFCF0E-474E-43C0-8591-343281C732B0}"/>
               </a:ext>
             </a:extLst>
           </p:cNvPr>
@@ -1782,7 +3342,7 @@
           <p:cNvPr id="5" name="">
             <a:extLst xmlns:a="http://schemas.openxmlformats.org/drawingml/2006/main">
               <a:ext uri="{FF2B5EF4-FFF2-40B4-BE49-F238E27FC236}">
-                <a16:creationId xmlns:a16="http://schemas.microsoft.com/office/drawing/2014/main" id="{D2C0D40C-C63D-4541-B724-5BABFAC514D3}"/>
+                <a16:creationId xmlns:a16="http://schemas.microsoft.com/office/drawing/2014/main" id="{E7F0061E-84E5-4573-9CBA-ACAAA0428B59}"/>
               </a:ext>
             </a:extLst>
           </p:cNvPr>
@@ -1860,7 +3420,7 @@
     </p:spTree>
     <p:extLst>
       <p:ext uri="{BB962C8B-B14F-4D97-AF65-F5344CB8AC3E}">
-        <p14:creationId xmlns:p14="http://schemas.microsoft.com/office/powerpoint/2010/main" val="1199223612"/>
+        <p14:creationId xmlns:p14="http://schemas.microsoft.com/office/powerpoint/2010/main" val="18724093"/>
       </p:ext>
     </p:extLst>
   </p:cSld>
@@ -1891,7 +3451,7 @@
           <p:cNvPr id="10" name="">
             <a:extLst xmlns:a="http://schemas.openxmlformats.org/drawingml/2006/main">
               <a:ext uri="{FF2B5EF4-FFF2-40B4-BE49-F238E27FC236}">
-                <a16:creationId xmlns:a16="http://schemas.microsoft.com/office/drawing/2014/main" id="{BB3A9013-A6AC-4746-BB1D-604A0FC0A52D}"/>
+                <a16:creationId xmlns:a16="http://schemas.microsoft.com/office/drawing/2014/main" id="{1E44CADF-5EA0-4604-8FCD-4B72B98B0DDC}"/>
               </a:ext>
             </a:extLst>
           </p:cNvPr>
@@ -1948,7 +3508,7 @@
           <p:cNvPr id="2" name="">
             <a:extLst xmlns:a="http://schemas.openxmlformats.org/drawingml/2006/main">
               <a:ext uri="{FF2B5EF4-FFF2-40B4-BE49-F238E27FC236}">
-                <a16:creationId xmlns:a16="http://schemas.microsoft.com/office/drawing/2014/main" id="{7CE99188-419E-4AC6-B022-F879F51D2B12}"/>
+                <a16:creationId xmlns:a16="http://schemas.microsoft.com/office/drawing/2014/main" id="{ABE0FCA6-F430-4003-943F-FA010C759EC1}"/>
               </a:ext>
             </a:extLst>
           </p:cNvPr>
@@ -2005,7 +3565,7 @@
           <p:cNvPr id="3" name="">
             <a:extLst xmlns:a="http://schemas.openxmlformats.org/drawingml/2006/main">
               <a:ext uri="{FF2B5EF4-FFF2-40B4-BE49-F238E27FC236}">
-                <a16:creationId xmlns:a16="http://schemas.microsoft.com/office/drawing/2014/main" id="{C21DA6D4-7322-4479-82F3-B2AF0E003CB8}"/>
+                <a16:creationId xmlns:a16="http://schemas.microsoft.com/office/drawing/2014/main" id="{1D4254F7-04EF-4C6D-A6FC-2E3234D34F89}"/>
               </a:ext>
             </a:extLst>
           </p:cNvPr>
@@ -2062,7 +3622,7 @@
           <p:cNvPr id="4" name="">
             <a:extLst xmlns:a="http://schemas.openxmlformats.org/drawingml/2006/main">
               <a:ext uri="{FF2B5EF4-FFF2-40B4-BE49-F238E27FC236}">
-                <a16:creationId xmlns:a16="http://schemas.microsoft.com/office/drawing/2014/main" id="{12A53D42-1FB0-4770-A144-86D3157E6642}"/>
+                <a16:creationId xmlns:a16="http://schemas.microsoft.com/office/drawing/2014/main" id="{5D458A7B-0A3B-4EE0-8EE1-A11B61C67CBC}"/>
               </a:ext>
             </a:extLst>
           </p:cNvPr>
@@ -2119,7 +3679,7 @@
           <p:cNvPr id="5" name="">
             <a:extLst xmlns:a="http://schemas.openxmlformats.org/drawingml/2006/main">
               <a:ext uri="{FF2B5EF4-FFF2-40B4-BE49-F238E27FC236}">
-                <a16:creationId xmlns:a16="http://schemas.microsoft.com/office/drawing/2014/main" id="{C2EDA75A-E328-481B-A037-17A7B49B353F}"/>
+                <a16:creationId xmlns:a16="http://schemas.microsoft.com/office/drawing/2014/main" id="{2C6EFC44-01F0-4D13-9F05-1904E03944F1}"/>
               </a:ext>
             </a:extLst>
           </p:cNvPr>
@@ -2222,7 +3782,7 @@
           <p:cNvPr id="6" name="">
             <a:extLst xmlns:a="http://schemas.openxmlformats.org/drawingml/2006/main">
               <a:ext uri="{FF2B5EF4-FFF2-40B4-BE49-F238E27FC236}">
-                <a16:creationId xmlns:a16="http://schemas.microsoft.com/office/drawing/2014/main" id="{6CA3704A-04E6-4E5A-9EDF-78F754881C1D}"/>
+                <a16:creationId xmlns:a16="http://schemas.microsoft.com/office/drawing/2014/main" id="{3F2C2CFA-9DBE-458C-92EA-AAC76A3A6FA3}"/>
               </a:ext>
             </a:extLst>
           </p:cNvPr>
@@ -2279,7 +3839,7 @@
           <p:cNvPr id="7" name="">
             <a:extLst xmlns:a="http://schemas.openxmlformats.org/drawingml/2006/main">
               <a:ext uri="{FF2B5EF4-FFF2-40B4-BE49-F238E27FC236}">
-                <a16:creationId xmlns:a16="http://schemas.microsoft.com/office/drawing/2014/main" id="{05AED115-44E4-4042-819C-BA27829E6809}"/>
+                <a16:creationId xmlns:a16="http://schemas.microsoft.com/office/drawing/2014/main" id="{3FEE42BC-3BF6-4CAB-AE58-D474D630CB65}"/>
               </a:ext>
             </a:extLst>
           </p:cNvPr>
@@ -2382,7 +3942,7 @@
           <p:cNvPr id="8" name="">
             <a:extLst xmlns:a="http://schemas.openxmlformats.org/drawingml/2006/main">
               <a:ext uri="{FF2B5EF4-FFF2-40B4-BE49-F238E27FC236}">
-                <a16:creationId xmlns:a16="http://schemas.microsoft.com/office/drawing/2014/main" id="{7ADD9BD2-EAD2-4832-AB09-E60601C950AA}"/>
+                <a16:creationId xmlns:a16="http://schemas.microsoft.com/office/drawing/2014/main" id="{84942DC3-C6DF-44F5-AD07-7F28B967A706}"/>
               </a:ext>
             </a:extLst>
           </p:cNvPr>
@@ -2439,7 +3999,7 @@
           <p:cNvPr id="9" name="">
             <a:extLst xmlns:a="http://schemas.openxmlformats.org/drawingml/2006/main">
               <a:ext uri="{FF2B5EF4-FFF2-40B4-BE49-F238E27FC236}">
-                <a16:creationId xmlns:a16="http://schemas.microsoft.com/office/drawing/2014/main" id="{9512C155-644E-4D42-ACC9-1103B429799E}"/>
+                <a16:creationId xmlns:a16="http://schemas.microsoft.com/office/drawing/2014/main" id="{05A57AC6-0C31-4B4D-9EEA-6A5E626E5838}"/>
               </a:ext>
             </a:extLst>
           </p:cNvPr>
@@ -2494,7 +4054,7 @@
     </p:spTree>
     <p:extLst>
       <p:ext uri="{BB962C8B-B14F-4D97-AF65-F5344CB8AC3E}">
-        <p14:creationId xmlns:p14="http://schemas.microsoft.com/office/powerpoint/2010/main" val="1510657568"/>
+        <p14:creationId xmlns:p14="http://schemas.microsoft.com/office/powerpoint/2010/main" val="1441194335"/>
       </p:ext>
     </p:extLst>
   </p:cSld>
@@ -2525,7 +4085,7 @@
           <p:cNvPr id="15" name="">
             <a:extLst xmlns:a="http://schemas.openxmlformats.org/drawingml/2006/main">
               <a:ext uri="{FF2B5EF4-FFF2-40B4-BE49-F238E27FC236}">
-                <a16:creationId xmlns:a16="http://schemas.microsoft.com/office/drawing/2014/main" id="{4A0BBC74-1EE0-4CA1-BFE9-7B0036CDC477}"/>
+                <a16:creationId xmlns:a16="http://schemas.microsoft.com/office/drawing/2014/main" id="{ABE5413A-74CE-4A5F-B29C-327B56E8A447}"/>
               </a:ext>
             </a:extLst>
           </p:cNvPr>
@@ -2582,7 +4142,7 @@
           <p:cNvPr id="2" name="">
             <a:extLst xmlns:a="http://schemas.openxmlformats.org/drawingml/2006/main">
               <a:ext uri="{FF2B5EF4-FFF2-40B4-BE49-F238E27FC236}">
-                <a16:creationId xmlns:a16="http://schemas.microsoft.com/office/drawing/2014/main" id="{E2550C62-33C7-4ECE-B89B-F6242A6F018A}"/>
+                <a16:creationId xmlns:a16="http://schemas.microsoft.com/office/drawing/2014/main" id="{A18C1216-2BB4-4677-94AC-CFB5FF8066BA}"/>
               </a:ext>
             </a:extLst>
           </p:cNvPr>
@@ -2639,7 +4199,7 @@
           <p:cNvPr id="3" name="">
             <a:extLst xmlns:a="http://schemas.openxmlformats.org/drawingml/2006/main">
               <a:ext uri="{FF2B5EF4-FFF2-40B4-BE49-F238E27FC236}">
-                <a16:creationId xmlns:a16="http://schemas.microsoft.com/office/drawing/2014/main" id="{BA618140-1764-47BB-893D-FD697E04F551}"/>
+                <a16:creationId xmlns:a16="http://schemas.microsoft.com/office/drawing/2014/main" id="{F8D3C6CB-61F9-4324-9F2E-47764FF7711C}"/>
               </a:ext>
             </a:extLst>
           </p:cNvPr>
@@ -2696,7 +4256,7 @@
           <p:cNvPr id="4" name="">
             <a:extLst xmlns:a="http://schemas.openxmlformats.org/drawingml/2006/main">
               <a:ext uri="{FF2B5EF4-FFF2-40B4-BE49-F238E27FC236}">
-                <a16:creationId xmlns:a16="http://schemas.microsoft.com/office/drawing/2014/main" id="{3DBDF7DA-EA22-4BA2-A9D1-E7DD4EF36880}"/>
+                <a16:creationId xmlns:a16="http://schemas.microsoft.com/office/drawing/2014/main" id="{329154B5-62D3-400C-8897-B499A00BA21B}"/>
               </a:ext>
             </a:extLst>
           </p:cNvPr>
@@ -2753,7 +4313,7 @@
           <p:cNvPr id="5" name="">
             <a:extLst xmlns:a="http://schemas.openxmlformats.org/drawingml/2006/main">
               <a:ext uri="{FF2B5EF4-FFF2-40B4-BE49-F238E27FC236}">
-                <a16:creationId xmlns:a16="http://schemas.microsoft.com/office/drawing/2014/main" id="{6A5935C5-35B6-4702-AB40-77167C979EDF}"/>
+                <a16:creationId xmlns:a16="http://schemas.microsoft.com/office/drawing/2014/main" id="{048EC8B8-A853-4583-BCD6-66EB16C0302D}"/>
               </a:ext>
             </a:extLst>
           </p:cNvPr>
@@ -2810,7 +4370,7 @@
           <p:cNvPr id="6" name="">
             <a:extLst xmlns:a="http://schemas.openxmlformats.org/drawingml/2006/main">
               <a:ext uri="{FF2B5EF4-FFF2-40B4-BE49-F238E27FC236}">
-                <a16:creationId xmlns:a16="http://schemas.microsoft.com/office/drawing/2014/main" id="{6521A1CA-9188-4642-B8C0-D13FD8D4F4D5}"/>
+                <a16:creationId xmlns:a16="http://schemas.microsoft.com/office/drawing/2014/main" id="{C10D61D8-2572-40B5-BF92-FA0A1C5FB5D5}"/>
               </a:ext>
             </a:extLst>
           </p:cNvPr>
@@ -2867,7 +4427,7 @@
           <p:cNvPr id="7" name="">
             <a:extLst xmlns:a="http://schemas.openxmlformats.org/drawingml/2006/main">
               <a:ext uri="{FF2B5EF4-FFF2-40B4-BE49-F238E27FC236}">
-                <a16:creationId xmlns:a16="http://schemas.microsoft.com/office/drawing/2014/main" id="{91380544-C746-4B04-A113-F0BD0158BCEC}"/>
+                <a16:creationId xmlns:a16="http://schemas.microsoft.com/office/drawing/2014/main" id="{8BDC22F5-1136-4F50-B64C-1EE8A6F3E9B6}"/>
               </a:ext>
             </a:extLst>
           </p:cNvPr>
@@ -2924,7 +4484,7 @@
           <p:cNvPr id="8" name="">
             <a:extLst xmlns:a="http://schemas.openxmlformats.org/drawingml/2006/main">
               <a:ext uri="{FF2B5EF4-FFF2-40B4-BE49-F238E27FC236}">
-                <a16:creationId xmlns:a16="http://schemas.microsoft.com/office/drawing/2014/main" id="{2B6EF01D-AB96-4B59-86D4-3FB57030018D}"/>
+                <a16:creationId xmlns:a16="http://schemas.microsoft.com/office/drawing/2014/main" id="{76D729A3-7CB0-443B-A56D-4F5275181DAB}"/>
               </a:ext>
             </a:extLst>
           </p:cNvPr>
@@ -2981,7 +4541,7 @@
           <p:cNvPr id="9" name="">
             <a:extLst xmlns:a="http://schemas.openxmlformats.org/drawingml/2006/main">
               <a:ext uri="{FF2B5EF4-FFF2-40B4-BE49-F238E27FC236}">
-                <a16:creationId xmlns:a16="http://schemas.microsoft.com/office/drawing/2014/main" id="{C5049BF0-1E33-4792-BF31-530068E1AB22}"/>
+                <a16:creationId xmlns:a16="http://schemas.microsoft.com/office/drawing/2014/main" id="{A7BA2944-809A-4441-8408-7C144AFB6195}"/>
               </a:ext>
             </a:extLst>
           </p:cNvPr>
@@ -3038,7 +4598,7 @@
           <p:cNvPr id="10" name="">
             <a:extLst xmlns:a="http://schemas.openxmlformats.org/drawingml/2006/main">
               <a:ext uri="{FF2B5EF4-FFF2-40B4-BE49-F238E27FC236}">
-                <a16:creationId xmlns:a16="http://schemas.microsoft.com/office/drawing/2014/main" id="{0F90916A-3C95-4314-AED1-597B64B39327}"/>
+                <a16:creationId xmlns:a16="http://schemas.microsoft.com/office/drawing/2014/main" id="{DA5192C5-BCED-412E-B2B3-8941DD99CB48}"/>
               </a:ext>
             </a:extLst>
           </p:cNvPr>
@@ -3095,7 +4655,7 @@
           <p:cNvPr id="11" name="">
             <a:extLst xmlns:a="http://schemas.openxmlformats.org/drawingml/2006/main">
               <a:ext uri="{FF2B5EF4-FFF2-40B4-BE49-F238E27FC236}">
-                <a16:creationId xmlns:a16="http://schemas.microsoft.com/office/drawing/2014/main" id="{82204DE1-9B5E-49D8-8AED-B1E3464AECFA}"/>
+                <a16:creationId xmlns:a16="http://schemas.microsoft.com/office/drawing/2014/main" id="{2E3F8AB3-F980-4BD9-8B2D-1851C35CFFFF}"/>
               </a:ext>
             </a:extLst>
           </p:cNvPr>
@@ -3152,7 +4712,7 @@
           <p:cNvPr id="12" name="">
             <a:extLst xmlns:a="http://schemas.openxmlformats.org/drawingml/2006/main">
               <a:ext uri="{FF2B5EF4-FFF2-40B4-BE49-F238E27FC236}">
-                <a16:creationId xmlns:a16="http://schemas.microsoft.com/office/drawing/2014/main" id="{DF8F29DF-B4C6-489E-9A04-BD51797110E3}"/>
+                <a16:creationId xmlns:a16="http://schemas.microsoft.com/office/drawing/2014/main" id="{6ECE486F-8F2D-4CD0-B9C8-D08437B46A16}"/>
               </a:ext>
             </a:extLst>
           </p:cNvPr>
@@ -3209,7 +4769,7 @@
           <p:cNvPr id="13" name="">
             <a:extLst xmlns:a="http://schemas.openxmlformats.org/drawingml/2006/main">
               <a:ext uri="{FF2B5EF4-FFF2-40B4-BE49-F238E27FC236}">
-                <a16:creationId xmlns:a16="http://schemas.microsoft.com/office/drawing/2014/main" id="{6BDAA070-465A-4017-90A6-09F6A3F566E1}"/>
+                <a16:creationId xmlns:a16="http://schemas.microsoft.com/office/drawing/2014/main" id="{E9ED72B2-BE7F-4281-B408-09A8896D8461}"/>
               </a:ext>
             </a:extLst>
           </p:cNvPr>
@@ -3266,7 +4826,7 @@
           <p:cNvPr id="14" name="">
             <a:extLst xmlns:a="http://schemas.openxmlformats.org/drawingml/2006/main">
               <a:ext uri="{FF2B5EF4-FFF2-40B4-BE49-F238E27FC236}">
-                <a16:creationId xmlns:a16="http://schemas.microsoft.com/office/drawing/2014/main" id="{B668C317-4763-4A67-AB88-1EF590D57C44}"/>
+                <a16:creationId xmlns:a16="http://schemas.microsoft.com/office/drawing/2014/main" id="{DE63AAFF-F90D-4753-9F26-191C8231CAA3}"/>
               </a:ext>
             </a:extLst>
           </p:cNvPr>
@@ -3321,7 +4881,7 @@
     </p:spTree>
     <p:extLst>
       <p:ext uri="{BB962C8B-B14F-4D97-AF65-F5344CB8AC3E}">
-        <p14:creationId xmlns:p14="http://schemas.microsoft.com/office/powerpoint/2010/main" val="1652837119"/>
+        <p14:creationId xmlns:p14="http://schemas.microsoft.com/office/powerpoint/2010/main" val="1770603386"/>
       </p:ext>
     </p:extLst>
   </p:cSld>
@@ -3352,7 +4912,7 @@
           <p:cNvPr id="11" name="">
             <a:extLst xmlns:a="http://schemas.openxmlformats.org/drawingml/2006/main">
               <a:ext uri="{FF2B5EF4-FFF2-40B4-BE49-F238E27FC236}">
-                <a16:creationId xmlns:a16="http://schemas.microsoft.com/office/drawing/2014/main" id="{34567FBE-C8D5-4E2B-A279-D9237C2A9337}"/>
+                <a16:creationId xmlns:a16="http://schemas.microsoft.com/office/drawing/2014/main" id="{61DDAFD6-D274-4227-98FA-00E9BB18EA96}"/>
               </a:ext>
             </a:extLst>
           </p:cNvPr>
@@ -3409,7 +4969,7 @@
           <p:cNvPr id="2" name="">
             <a:extLst xmlns:a="http://schemas.openxmlformats.org/drawingml/2006/main">
               <a:ext uri="{FF2B5EF4-FFF2-40B4-BE49-F238E27FC236}">
-                <a16:creationId xmlns:a16="http://schemas.microsoft.com/office/drawing/2014/main" id="{5FAEB7C1-2DF5-422D-9D6D-D197B3FFD155}"/>
+                <a16:creationId xmlns:a16="http://schemas.microsoft.com/office/drawing/2014/main" id="{C23650B3-BBAC-4D25-8F95-CDE4D74735F2}"/>
               </a:ext>
             </a:extLst>
           </p:cNvPr>
@@ -3466,7 +5026,7 @@
           <p:cNvPr id="3" name="">
             <a:extLst xmlns:a="http://schemas.openxmlformats.org/drawingml/2006/main">
               <a:ext uri="{FF2B5EF4-FFF2-40B4-BE49-F238E27FC236}">
-                <a16:creationId xmlns:a16="http://schemas.microsoft.com/office/drawing/2014/main" id="{8EE23EE5-FB39-472B-B2A1-DE11FF41C516}"/>
+                <a16:creationId xmlns:a16="http://schemas.microsoft.com/office/drawing/2014/main" id="{8903CA2D-6C73-451F-8290-DEB66EF3D917}"/>
               </a:ext>
             </a:extLst>
           </p:cNvPr>
@@ -3523,7 +5083,7 @@
           <p:cNvPr id="4" name="">
             <a:extLst xmlns:a="http://schemas.openxmlformats.org/drawingml/2006/main">
               <a:ext uri="{FF2B5EF4-FFF2-40B4-BE49-F238E27FC236}">
-                <a16:creationId xmlns:a16="http://schemas.microsoft.com/office/drawing/2014/main" id="{1909AE17-AF05-46F0-8AE7-4C0671AD43F2}"/>
+                <a16:creationId xmlns:a16="http://schemas.microsoft.com/office/drawing/2014/main" id="{CB71E1D6-82FC-445B-ADDD-4DC84144C27B}"/>
               </a:ext>
             </a:extLst>
           </p:cNvPr>
@@ -3580,7 +5140,7 @@
           <p:cNvPr id="5" name="">
             <a:extLst xmlns:a="http://schemas.openxmlformats.org/drawingml/2006/main">
               <a:ext uri="{FF2B5EF4-FFF2-40B4-BE49-F238E27FC236}">
-                <a16:creationId xmlns:a16="http://schemas.microsoft.com/office/drawing/2014/main" id="{5F393474-22DA-49B8-A897-E4E98B8E1E27}"/>
+                <a16:creationId xmlns:a16="http://schemas.microsoft.com/office/drawing/2014/main" id="{2C3EC3C0-BE4C-4FCC-BAAC-03A46B06CFB2}"/>
               </a:ext>
             </a:extLst>
           </p:cNvPr>
@@ -3637,7 +5197,7 @@
           <p:cNvPr id="6" name="">
             <a:extLst xmlns:a="http://schemas.openxmlformats.org/drawingml/2006/main">
               <a:ext uri="{FF2B5EF4-FFF2-40B4-BE49-F238E27FC236}">
-                <a16:creationId xmlns:a16="http://schemas.microsoft.com/office/drawing/2014/main" id="{BC722188-3C5E-405B-B976-4065BD142A53}"/>
+                <a16:creationId xmlns:a16="http://schemas.microsoft.com/office/drawing/2014/main" id="{E7067792-D06B-48DD-A5C2-392D3A0116C1}"/>
               </a:ext>
             </a:extLst>
           </p:cNvPr>
@@ -3717,7 +5277,7 @@
           <p:cNvPr id="7" name="">
             <a:extLst xmlns:a="http://schemas.openxmlformats.org/drawingml/2006/main">
               <a:ext uri="{FF2B5EF4-FFF2-40B4-BE49-F238E27FC236}">
-                <a16:creationId xmlns:a16="http://schemas.microsoft.com/office/drawing/2014/main" id="{E72C2A86-9E36-4B48-969E-B38C65914AFB}"/>
+                <a16:creationId xmlns:a16="http://schemas.microsoft.com/office/drawing/2014/main" id="{CFA607D7-F0DF-4DCF-9877-ED2E89184934}"/>
               </a:ext>
             </a:extLst>
           </p:cNvPr>
@@ -3774,7 +5334,7 @@
           <p:cNvPr id="8" name="">
             <a:extLst xmlns:a="http://schemas.openxmlformats.org/drawingml/2006/main">
               <a:ext uri="{FF2B5EF4-FFF2-40B4-BE49-F238E27FC236}">
-                <a16:creationId xmlns:a16="http://schemas.microsoft.com/office/drawing/2014/main" id="{1B497922-F600-4214-88B9-556CC8310736}"/>
+                <a16:creationId xmlns:a16="http://schemas.microsoft.com/office/drawing/2014/main" id="{BAEA3842-F1EE-49CA-81E5-DF1E1E4C6671}"/>
               </a:ext>
             </a:extLst>
           </p:cNvPr>
@@ -3831,7 +5391,7 @@
           <p:cNvPr id="9" name="">
             <a:extLst xmlns:a="http://schemas.openxmlformats.org/drawingml/2006/main">
               <a:ext uri="{FF2B5EF4-FFF2-40B4-BE49-F238E27FC236}">
-                <a16:creationId xmlns:a16="http://schemas.microsoft.com/office/drawing/2014/main" id="{04E48999-DF32-4714-9D4E-8740A74F5DDF}"/>
+                <a16:creationId xmlns:a16="http://schemas.microsoft.com/office/drawing/2014/main" id="{FDA86E1C-12C7-4A53-A76E-4A4FC4B6DFD1}"/>
               </a:ext>
             </a:extLst>
           </p:cNvPr>
@@ -3911,7 +5471,7 @@
           <p:cNvPr id="10" name="">
             <a:extLst xmlns:a="http://schemas.openxmlformats.org/drawingml/2006/main">
               <a:ext uri="{FF2B5EF4-FFF2-40B4-BE49-F238E27FC236}">
-                <a16:creationId xmlns:a16="http://schemas.microsoft.com/office/drawing/2014/main" id="{17EB7FB7-D4FE-4504-A1B3-CFD0711F16C8}"/>
+                <a16:creationId xmlns:a16="http://schemas.microsoft.com/office/drawing/2014/main" id="{38F4BF42-6592-476B-BA0D-C83C8F4ADC95}"/>
               </a:ext>
             </a:extLst>
           </p:cNvPr>
@@ -3966,7 +5526,7 @@
     </p:spTree>
     <p:extLst>
       <p:ext uri="{BB962C8B-B14F-4D97-AF65-F5344CB8AC3E}">
-        <p14:creationId xmlns:p14="http://schemas.microsoft.com/office/powerpoint/2010/main" val="1558622408"/>
+        <p14:creationId xmlns:p14="http://schemas.microsoft.com/office/powerpoint/2010/main" val="59512959"/>
       </p:ext>
     </p:extLst>
   </p:cSld>
@@ -3997,7 +5557,7 @@
           <p:cNvPr id="14" name="">
             <a:extLst xmlns:a="http://schemas.openxmlformats.org/drawingml/2006/main">
               <a:ext uri="{FF2B5EF4-FFF2-40B4-BE49-F238E27FC236}">
-                <a16:creationId xmlns:a16="http://schemas.microsoft.com/office/drawing/2014/main" id="{B8E7AF78-FEE1-4A82-AA74-43663CAD2189}"/>
+                <a16:creationId xmlns:a16="http://schemas.microsoft.com/office/drawing/2014/main" id="{AC22EAB3-641F-48FB-9D86-E8A589DFFF6F}"/>
               </a:ext>
             </a:extLst>
           </p:cNvPr>
@@ -4054,7 +5614,7 @@
           <p:cNvPr id="2" name="">
             <a:extLst xmlns:a="http://schemas.openxmlformats.org/drawingml/2006/main">
               <a:ext uri="{FF2B5EF4-FFF2-40B4-BE49-F238E27FC236}">
-                <a16:creationId xmlns:a16="http://schemas.microsoft.com/office/drawing/2014/main" id="{4DAEDA89-5E2E-4B0F-A56A-E40760E47CBA}"/>
+                <a16:creationId xmlns:a16="http://schemas.microsoft.com/office/drawing/2014/main" id="{199EBF99-8CD8-4C36-941A-46E32065A17F}"/>
               </a:ext>
             </a:extLst>
           </p:cNvPr>
@@ -4101,7 +5661,7 @@
                 <a:ea typeface="Arial"/>
                 <a:cs typeface="Arial"/>
               </a:rPr>
-              <a:t>AssemblyAI handles the conversation</a:t>
+              <a:t>AssemblyAI powers speech and planning</a:t>
             </a:r>
           </a:p>
         </p:txBody>
@@ -4111,7 +5671,7 @@
           <p:cNvPr id="3" name="">
             <a:extLst xmlns:a="http://schemas.openxmlformats.org/drawingml/2006/main">
               <a:ext uri="{FF2B5EF4-FFF2-40B4-BE49-F238E27FC236}">
-                <a16:creationId xmlns:a16="http://schemas.microsoft.com/office/drawing/2014/main" id="{CD0B2853-A3EA-4731-B64B-F3024F0029D2}"/>
+                <a16:creationId xmlns:a16="http://schemas.microsoft.com/office/drawing/2014/main" id="{A46C6C7F-9E38-4FFC-B3E2-E481E6E3FDE0}"/>
               </a:ext>
             </a:extLst>
           </p:cNvPr>
@@ -4168,7 +5728,7 @@
           <p:cNvPr id="4" name="">
             <a:extLst xmlns:a="http://schemas.openxmlformats.org/drawingml/2006/main">
               <a:ext uri="{FF2B5EF4-FFF2-40B4-BE49-F238E27FC236}">
-                <a16:creationId xmlns:a16="http://schemas.microsoft.com/office/drawing/2014/main" id="{BA91B262-0B16-4EA9-9F00-0B76EB8A67DD}"/>
+                <a16:creationId xmlns:a16="http://schemas.microsoft.com/office/drawing/2014/main" id="{07871EF5-01EE-4757-991A-037D7B10944E}"/>
               </a:ext>
             </a:extLst>
           </p:cNvPr>
@@ -4225,7 +5785,7 @@
           <p:cNvPr id="5" name="">
             <a:extLst xmlns:a="http://schemas.openxmlformats.org/drawingml/2006/main">
               <a:ext uri="{FF2B5EF4-FFF2-40B4-BE49-F238E27FC236}">
-                <a16:creationId xmlns:a16="http://schemas.microsoft.com/office/drawing/2014/main" id="{99F46F5A-4DF8-44E9-8526-D454A571DE97}"/>
+                <a16:creationId xmlns:a16="http://schemas.microsoft.com/office/drawing/2014/main" id="{742C4298-7DD8-4373-B168-C2527A47780E}"/>
               </a:ext>
             </a:extLst>
           </p:cNvPr>
@@ -4282,7 +5842,7 @@
           <p:cNvPr id="6" name="">
             <a:extLst xmlns:a="http://schemas.openxmlformats.org/drawingml/2006/main">
               <a:ext uri="{FF2B5EF4-FFF2-40B4-BE49-F238E27FC236}">
-                <a16:creationId xmlns:a16="http://schemas.microsoft.com/office/drawing/2014/main" id="{FC6989AC-AE84-462D-A1F3-0316C863111D}"/>
+                <a16:creationId xmlns:a16="http://schemas.microsoft.com/office/drawing/2014/main" id="{6DEBD2C5-42EE-4558-AACD-421BEC877BD0}"/>
               </a:ext>
             </a:extLst>
           </p:cNvPr>
@@ -4385,7 +5945,7 @@
           <p:cNvPr id="7" name="">
             <a:extLst xmlns:a="http://schemas.openxmlformats.org/drawingml/2006/main">
               <a:ext uri="{FF2B5EF4-FFF2-40B4-BE49-F238E27FC236}">
-                <a16:creationId xmlns:a16="http://schemas.microsoft.com/office/drawing/2014/main" id="{0DAF7DF4-096C-4251-910C-C3E2703BE7DE}"/>
+                <a16:creationId xmlns:a16="http://schemas.microsoft.com/office/drawing/2014/main" id="{887F435F-3AD8-4E5D-9302-EABA9FA78A00}"/>
               </a:ext>
             </a:extLst>
           </p:cNvPr>
@@ -4442,7 +6002,7 @@
           <p:cNvPr id="8" name="">
             <a:extLst xmlns:a="http://schemas.openxmlformats.org/drawingml/2006/main">
               <a:ext uri="{FF2B5EF4-FFF2-40B4-BE49-F238E27FC236}">
-                <a16:creationId xmlns:a16="http://schemas.microsoft.com/office/drawing/2014/main" id="{9F787B43-1C2D-4F13-B137-50B2458A3E1C}"/>
+                <a16:creationId xmlns:a16="http://schemas.microsoft.com/office/drawing/2014/main" id="{1AD14C69-B371-4197-A2B0-17C5699FC906}"/>
               </a:ext>
             </a:extLst>
           </p:cNvPr>
@@ -4489,7 +6049,7 @@
                 <a:ea typeface="Arial"/>
                 <a:cs typeface="Arial"/>
               </a:rPr>
-              <a:t>Voice Agent API</a:t>
+              <a:t>AssemblyAI</a:t>
             </a:r>
           </a:p>
         </p:txBody>
@@ -4499,7 +6059,7 @@
           <p:cNvPr id="9" name="">
             <a:extLst xmlns:a="http://schemas.openxmlformats.org/drawingml/2006/main">
               <a:ext uri="{FF2B5EF4-FFF2-40B4-BE49-F238E27FC236}">
-                <a16:creationId xmlns:a16="http://schemas.microsoft.com/office/drawing/2014/main" id="{ED63D52A-EFCA-4745-A230-574844710C43}"/>
+                <a16:creationId xmlns:a16="http://schemas.microsoft.com/office/drawing/2014/main" id="{8D82D7EF-24F3-48AE-9D6A-ED1F45ECFDB9}"/>
               </a:ext>
             </a:extLst>
           </p:cNvPr>
@@ -4546,7 +6106,7 @@
                 <a:ea typeface="Arial"/>
                 <a:cs typeface="Arial"/>
               </a:rPr>
-              <a:t>Streaming speech input</a:t>
+              <a:t>Voice Agent conversation</a:t>
             </a:r>
           </a:p>
           <a:p xmlns:a="http://schemas.openxmlformats.org/drawingml/2006/main">
@@ -4569,7 +6129,7 @@
                 <a:ea typeface="Arial"/>
                 <a:cs typeface="Arial"/>
               </a:rPr>
-              <a:t>Conversational response</a:t>
+              <a:t>LLM Gateway JSON plans</a:t>
             </a:r>
           </a:p>
           <a:p xmlns:a="http://schemas.openxmlformats.org/drawingml/2006/main">
@@ -4592,7 +6152,7 @@
                 <a:ea typeface="Arial"/>
                 <a:cs typeface="Arial"/>
               </a:rPr>
-              <a:t>Structured function tools</a:t>
+              <a:t>Proposed board changes</a:t>
             </a:r>
           </a:p>
         </p:txBody>
@@ -4602,7 +6162,7 @@
           <p:cNvPr id="10" name="">
             <a:extLst xmlns:a="http://schemas.openxmlformats.org/drawingml/2006/main">
               <a:ext uri="{FF2B5EF4-FFF2-40B4-BE49-F238E27FC236}">
-                <a16:creationId xmlns:a16="http://schemas.microsoft.com/office/drawing/2014/main" id="{ED519D47-5C34-4B43-8225-1DFEC9A2A32E}"/>
+                <a16:creationId xmlns:a16="http://schemas.microsoft.com/office/drawing/2014/main" id="{C4BD21B2-5FC4-459B-928F-4C54B719459C}"/>
               </a:ext>
             </a:extLst>
           </p:cNvPr>
@@ -4659,7 +6219,7 @@
           <p:cNvPr id="11" name="">
             <a:extLst xmlns:a="http://schemas.openxmlformats.org/drawingml/2006/main">
               <a:ext uri="{FF2B5EF4-FFF2-40B4-BE49-F238E27FC236}">
-                <a16:creationId xmlns:a16="http://schemas.microsoft.com/office/drawing/2014/main" id="{3B7A4F7A-EA02-4BDC-98DD-4FF4BA48A533}"/>
+                <a16:creationId xmlns:a16="http://schemas.microsoft.com/office/drawing/2014/main" id="{CA955C51-6613-4444-9D37-F52D8D65F67D}"/>
               </a:ext>
             </a:extLst>
           </p:cNvPr>
@@ -4716,7 +6276,7 @@
           <p:cNvPr id="12" name="">
             <a:extLst xmlns:a="http://schemas.openxmlformats.org/drawingml/2006/main">
               <a:ext uri="{FF2B5EF4-FFF2-40B4-BE49-F238E27FC236}">
-                <a16:creationId xmlns:a16="http://schemas.microsoft.com/office/drawing/2014/main" id="{1056BB89-6006-412B-A721-7103F700C302}"/>
+                <a16:creationId xmlns:a16="http://schemas.microsoft.com/office/drawing/2014/main" id="{CE83631D-E82D-41B1-87AB-6C55155181A9}"/>
               </a:ext>
             </a:extLst>
           </p:cNvPr>
@@ -4819,7 +6379,7 @@
           <p:cNvPr id="13" name="">
             <a:extLst xmlns:a="http://schemas.openxmlformats.org/drawingml/2006/main">
               <a:ext uri="{FF2B5EF4-FFF2-40B4-BE49-F238E27FC236}">
-                <a16:creationId xmlns:a16="http://schemas.microsoft.com/office/drawing/2014/main" id="{27A8EEFF-5C35-4FEF-A8DC-F8689249FF2F}"/>
+                <a16:creationId xmlns:a16="http://schemas.microsoft.com/office/drawing/2014/main" id="{9B02D658-3E0F-4B9E-ACC4-B665CCA50989}"/>
               </a:ext>
             </a:extLst>
           </p:cNvPr>
@@ -4866,7 +6426,7 @@
                 <a:ea typeface="Arial"/>
                 <a:cs typeface="Arial"/>
               </a:rPr>
-              <a:t>Server issues temporary tokens. Audio goes to AssemblyAI. Synthetic records stay in this browser.</a:t>
+              <a:t>Server protects the key. AssemblyAI processes audio and text. Browser records remain local.</a:t>
             </a:r>
           </a:p>
         </p:txBody>
@@ -4874,7 +6434,7 @@
     </p:spTree>
     <p:extLst>
       <p:ext uri="{BB962C8B-B14F-4D97-AF65-F5344CB8AC3E}">
-        <p14:creationId xmlns:p14="http://schemas.microsoft.com/office/powerpoint/2010/main" val="372713040"/>
+        <p14:creationId xmlns:p14="http://schemas.microsoft.com/office/powerpoint/2010/main" val="1662391313"/>
       </p:ext>
     </p:extLst>
   </p:cSld>
@@ -4905,7 +6465,7 @@
           <p:cNvPr id="10" name="">
             <a:extLst xmlns:a="http://schemas.openxmlformats.org/drawingml/2006/main">
               <a:ext uri="{FF2B5EF4-FFF2-40B4-BE49-F238E27FC236}">
-                <a16:creationId xmlns:a16="http://schemas.microsoft.com/office/drawing/2014/main" id="{C8F2814D-FFAB-4DBA-A19B-22BBA42CA73C}"/>
+                <a16:creationId xmlns:a16="http://schemas.microsoft.com/office/drawing/2014/main" id="{11F63554-BEA0-4E73-B5A1-9FD32530E1B7}"/>
               </a:ext>
             </a:extLst>
           </p:cNvPr>
@@ -4962,7 +6522,7 @@
           <p:cNvPr id="2" name="">
             <a:extLst xmlns:a="http://schemas.openxmlformats.org/drawingml/2006/main">
               <a:ext uri="{FF2B5EF4-FFF2-40B4-BE49-F238E27FC236}">
-                <a16:creationId xmlns:a16="http://schemas.microsoft.com/office/drawing/2014/main" id="{3874C590-02D9-4447-8288-D3FD5957F3F0}"/>
+                <a16:creationId xmlns:a16="http://schemas.microsoft.com/office/drawing/2014/main" id="{045478D7-235D-4DD7-B972-2425CAD1FD29}"/>
               </a:ext>
             </a:extLst>
           </p:cNvPr>
@@ -5019,7 +6579,7 @@
           <p:cNvPr id="3" name="">
             <a:extLst xmlns:a="http://schemas.openxmlformats.org/drawingml/2006/main">
               <a:ext uri="{FF2B5EF4-FFF2-40B4-BE49-F238E27FC236}">
-                <a16:creationId xmlns:a16="http://schemas.microsoft.com/office/drawing/2014/main" id="{F1F06AAB-EFBB-4DC4-B0A1-7637C95D2532}"/>
+                <a16:creationId xmlns:a16="http://schemas.microsoft.com/office/drawing/2014/main" id="{9763ED52-5F50-49FE-B17B-5B2C2AC67436}"/>
               </a:ext>
             </a:extLst>
           </p:cNvPr>
@@ -5076,7 +6636,7 @@
           <p:cNvPr id="4" name="">
             <a:extLst xmlns:a="http://schemas.openxmlformats.org/drawingml/2006/main">
               <a:ext uri="{FF2B5EF4-FFF2-40B4-BE49-F238E27FC236}">
-                <a16:creationId xmlns:a16="http://schemas.microsoft.com/office/drawing/2014/main" id="{067F0890-CD91-4836-8CCA-513CA8E3174D}"/>
+                <a16:creationId xmlns:a16="http://schemas.microsoft.com/office/drawing/2014/main" id="{88705C56-15E1-4A24-8F87-BF5A084E7875}"/>
               </a:ext>
             </a:extLst>
           </p:cNvPr>
@@ -5133,7 +6693,7 @@
           <p:cNvPr id="5" name="">
             <a:extLst xmlns:a="http://schemas.openxmlformats.org/drawingml/2006/main">
               <a:ext uri="{FF2B5EF4-FFF2-40B4-BE49-F238E27FC236}">
-                <a16:creationId xmlns:a16="http://schemas.microsoft.com/office/drawing/2014/main" id="{B20AF011-72FC-44FA-B471-1DE9211B2164}"/>
+                <a16:creationId xmlns:a16="http://schemas.microsoft.com/office/drawing/2014/main" id="{0D6A7A09-3AD5-47B1-B755-03399E5556EB}"/>
               </a:ext>
             </a:extLst>
           </p:cNvPr>
@@ -5213,7 +6773,7 @@
           <p:cNvPr id="6" name="">
             <a:extLst xmlns:a="http://schemas.openxmlformats.org/drawingml/2006/main">
               <a:ext uri="{FF2B5EF4-FFF2-40B4-BE49-F238E27FC236}">
-                <a16:creationId xmlns:a16="http://schemas.microsoft.com/office/drawing/2014/main" id="{D8AD55AA-42D7-4797-BB25-266EE83FBF7D}"/>
+                <a16:creationId xmlns:a16="http://schemas.microsoft.com/office/drawing/2014/main" id="{0E7BFCE1-6A27-4A39-8211-56886A4E9505}"/>
               </a:ext>
             </a:extLst>
           </p:cNvPr>
@@ -5270,7 +6830,7 @@
           <p:cNvPr id="7" name="">
             <a:extLst xmlns:a="http://schemas.openxmlformats.org/drawingml/2006/main">
               <a:ext uri="{FF2B5EF4-FFF2-40B4-BE49-F238E27FC236}">
-                <a16:creationId xmlns:a16="http://schemas.microsoft.com/office/drawing/2014/main" id="{56DD2FF9-B33F-431A-A7C2-B330E01BCA0A}"/>
+                <a16:creationId xmlns:a16="http://schemas.microsoft.com/office/drawing/2014/main" id="{1D1195F2-4FEF-467F-9505-AF2D083D65A9}"/>
               </a:ext>
             </a:extLst>
           </p:cNvPr>
@@ -5373,7 +6933,7 @@
           <p:cNvPr id="8" name="">
             <a:extLst xmlns:a="http://schemas.openxmlformats.org/drawingml/2006/main">
               <a:ext uri="{FF2B5EF4-FFF2-40B4-BE49-F238E27FC236}">
-                <a16:creationId xmlns:a16="http://schemas.microsoft.com/office/drawing/2014/main" id="{9868F231-7B45-47EA-9068-B9496EB8F35A}"/>
+                <a16:creationId xmlns:a16="http://schemas.microsoft.com/office/drawing/2014/main" id="{4F24DE8C-1BAE-46C5-B4B6-C52B1FFC9471}"/>
               </a:ext>
             </a:extLst>
           </p:cNvPr>
@@ -5430,7 +6990,7 @@
           <p:cNvPr id="9" name="">
             <a:extLst xmlns:a="http://schemas.openxmlformats.org/drawingml/2006/main">
               <a:ext uri="{FF2B5EF4-FFF2-40B4-BE49-F238E27FC236}">
-                <a16:creationId xmlns:a16="http://schemas.microsoft.com/office/drawing/2014/main" id="{28C36B96-0291-4D7F-999E-F132764BA469}"/>
+                <a16:creationId xmlns:a16="http://schemas.microsoft.com/office/drawing/2014/main" id="{633BC5C1-5033-40F1-B852-98FF2EA3156D}"/>
               </a:ext>
             </a:extLst>
           </p:cNvPr>
@@ -5485,7 +7045,7 @@
     </p:spTree>
     <p:extLst>
       <p:ext uri="{BB962C8B-B14F-4D97-AF65-F5344CB8AC3E}">
-        <p14:creationId xmlns:p14="http://schemas.microsoft.com/office/powerpoint/2010/main" val="1954554235"/>
+        <p14:creationId xmlns:p14="http://schemas.microsoft.com/office/powerpoint/2010/main" val="199413462"/>
       </p:ext>
     </p:extLst>
   </p:cSld>
@@ -5516,7 +7076,7 @@
           <p:cNvPr id="10" name="">
             <a:extLst xmlns:a="http://schemas.openxmlformats.org/drawingml/2006/main">
               <a:ext uri="{FF2B5EF4-FFF2-40B4-BE49-F238E27FC236}">
-                <a16:creationId xmlns:a16="http://schemas.microsoft.com/office/drawing/2014/main" id="{B4279303-5434-4A80-9B26-0CC7EFBEFD63}"/>
+                <a16:creationId xmlns:a16="http://schemas.microsoft.com/office/drawing/2014/main" id="{673E53F4-065B-418C-82F7-96153C1D908E}"/>
               </a:ext>
             </a:extLst>
           </p:cNvPr>
@@ -5573,7 +7133,7 @@
           <p:cNvPr id="2" name="">
             <a:extLst xmlns:a="http://schemas.openxmlformats.org/drawingml/2006/main">
               <a:ext uri="{FF2B5EF4-FFF2-40B4-BE49-F238E27FC236}">
-                <a16:creationId xmlns:a16="http://schemas.microsoft.com/office/drawing/2014/main" id="{142FF5AB-27B9-4618-A3F8-DECCCF20B565}"/>
+                <a16:creationId xmlns:a16="http://schemas.microsoft.com/office/drawing/2014/main" id="{601F463B-415E-4399-9EA3-2EAE34E62458}"/>
               </a:ext>
             </a:extLst>
           </p:cNvPr>
@@ -5630,7 +7190,7 @@
           <p:cNvPr id="3" name="">
             <a:extLst xmlns:a="http://schemas.openxmlformats.org/drawingml/2006/main">
               <a:ext uri="{FF2B5EF4-FFF2-40B4-BE49-F238E27FC236}">
-                <a16:creationId xmlns:a16="http://schemas.microsoft.com/office/drawing/2014/main" id="{44648C3F-DB5B-4D5F-BE81-689C6D75CCDC}"/>
+                <a16:creationId xmlns:a16="http://schemas.microsoft.com/office/drawing/2014/main" id="{271B22F7-AA82-4F71-AD02-8FC3F7E5621E}"/>
               </a:ext>
             </a:extLst>
           </p:cNvPr>
@@ -5687,7 +7247,7 @@
           <p:cNvPr id="4" name="">
             <a:extLst xmlns:a="http://schemas.openxmlformats.org/drawingml/2006/main">
               <a:ext uri="{FF2B5EF4-FFF2-40B4-BE49-F238E27FC236}">
-                <a16:creationId xmlns:a16="http://schemas.microsoft.com/office/drawing/2014/main" id="{091D5F62-3C17-455B-88AC-00FED4F57CD4}"/>
+                <a16:creationId xmlns:a16="http://schemas.microsoft.com/office/drawing/2014/main" id="{E6BF3474-A165-492E-AF03-6A22091940DE}"/>
               </a:ext>
             </a:extLst>
           </p:cNvPr>
@@ -5734,7 +7294,7 @@
                 <a:ea typeface="Arial"/>
                 <a:cs typeface="Arial"/>
               </a:rPr>
-              <a:t>20 deterministic tests passed</a:t>
+              <a:t>78 automated checks passed</a:t>
             </a:r>
           </a:p>
         </p:txBody>
@@ -5744,7 +7304,7 @@
           <p:cNvPr id="5" name="">
             <a:extLst xmlns:a="http://schemas.openxmlformats.org/drawingml/2006/main">
               <a:ext uri="{FF2B5EF4-FFF2-40B4-BE49-F238E27FC236}">
-                <a16:creationId xmlns:a16="http://schemas.microsoft.com/office/drawing/2014/main" id="{46BE7378-3FF5-463A-95EC-32EECC37982A}"/>
+                <a16:creationId xmlns:a16="http://schemas.microsoft.com/office/drawing/2014/main" id="{081B825D-3C5A-4E2D-B75A-4CD63E06D30C}"/>
               </a:ext>
             </a:extLst>
           </p:cNvPr>
@@ -5791,7 +7351,7 @@
                 <a:ea typeface="Arial"/>
                 <a:cs typeface="Arial"/>
               </a:rPr>
-              <a:t>State-engine checks: 20 / 20 passing</a:t>
+              <a:t>State, storage, access and planner checks passed</a:t>
             </a:r>
           </a:p>
         </p:txBody>
@@ -5801,7 +7361,7 @@
           <p:cNvPr id="6" name="">
             <a:extLst xmlns:a="http://schemas.openxmlformats.org/drawingml/2006/main">
               <a:ext uri="{FF2B5EF4-FFF2-40B4-BE49-F238E27FC236}">
-                <a16:creationId xmlns:a16="http://schemas.microsoft.com/office/drawing/2014/main" id="{F69CAAC2-962F-4D43-86D5-2FCFAB7A76C5}"/>
+                <a16:creationId xmlns:a16="http://schemas.microsoft.com/office/drawing/2014/main" id="{20EDB611-AA74-4FB1-8E05-FDAAAD959A26}"/>
               </a:ext>
             </a:extLst>
           </p:cNvPr>
@@ -5848,7 +7408,7 @@
                 <a:ea typeface="Arial"/>
                 <a:cs typeface="Arial"/>
               </a:rPr>
-              <a:t>Voice session connected; full flow still under review</a:t>
+              <a:t>One synthetic spoken fixture reached validated board state</a:t>
             </a:r>
           </a:p>
         </p:txBody>
@@ -5858,7 +7418,7 @@
           <p:cNvPr id="7" name="">
             <a:extLst xmlns:a="http://schemas.openxmlformats.org/drawingml/2006/main">
               <a:ext uri="{FF2B5EF4-FFF2-40B4-BE49-F238E27FC236}">
-                <a16:creationId xmlns:a16="http://schemas.microsoft.com/office/drawing/2014/main" id="{3054D99A-AA9F-4E17-8BEE-1CA2153B6BA6}"/>
+                <a16:creationId xmlns:a16="http://schemas.microsoft.com/office/drawing/2014/main" id="{24011C35-D029-4D9A-A636-DBE3A9479F46}"/>
               </a:ext>
             </a:extLst>
           </p:cNvPr>
@@ -5905,7 +7465,7 @@
                 <a:ea typeface="Arial"/>
                 <a:cs typeface="Arial"/>
               </a:rPr>
-              <a:t>Clinical outcomes and live reliability: not established</a:t>
+              <a:t>Device microphone and clinical reliability remain unvalidated</a:t>
             </a:r>
           </a:p>
         </p:txBody>
@@ -5915,7 +7475,7 @@
           <p:cNvPr id="8" name="">
             <a:extLst xmlns:a="http://schemas.openxmlformats.org/drawingml/2006/main">
               <a:ext uri="{FF2B5EF4-FFF2-40B4-BE49-F238E27FC236}">
-                <a16:creationId xmlns:a16="http://schemas.microsoft.com/office/drawing/2014/main" id="{FEAF6243-7C16-4E13-85CF-2961200D848A}"/>
+                <a16:creationId xmlns:a16="http://schemas.microsoft.com/office/drawing/2014/main" id="{581F699D-1F5A-4415-9836-0567F226B395}"/>
               </a:ext>
             </a:extLst>
           </p:cNvPr>
@@ -5972,7 +7532,7 @@
           <p:cNvPr id="9" name="">
             <a:extLst xmlns:a="http://schemas.openxmlformats.org/drawingml/2006/main">
               <a:ext uri="{FF2B5EF4-FFF2-40B4-BE49-F238E27FC236}">
-                <a16:creationId xmlns:a16="http://schemas.microsoft.com/office/drawing/2014/main" id="{704307BC-4021-4343-BE74-C9EB1E55A8F7}"/>
+                <a16:creationId xmlns:a16="http://schemas.microsoft.com/office/drawing/2014/main" id="{A224F286-0672-43E9-93F9-5C6632D2F88A}"/>
               </a:ext>
             </a:extLst>
           </p:cNvPr>
@@ -6027,7 +7587,7 @@
     </p:spTree>
     <p:extLst>
       <p:ext uri="{BB962C8B-B14F-4D97-AF65-F5344CB8AC3E}">
-        <p14:creationId xmlns:p14="http://schemas.microsoft.com/office/powerpoint/2010/main" val="1920809248"/>
+        <p14:creationId xmlns:p14="http://schemas.microsoft.com/office/powerpoint/2010/main" val="761598090"/>
       </p:ext>
     </p:extLst>
   </p:cSld>
@@ -6058,7 +7618,7 @@
           <p:cNvPr id="7" name="">
             <a:extLst xmlns:a="http://schemas.openxmlformats.org/drawingml/2006/main">
               <a:ext uri="{FF2B5EF4-FFF2-40B4-BE49-F238E27FC236}">
-                <a16:creationId xmlns:a16="http://schemas.microsoft.com/office/drawing/2014/main" id="{28937343-CB6A-4FE8-A68E-4AE7C5DF1912}"/>
+                <a16:creationId xmlns:a16="http://schemas.microsoft.com/office/drawing/2014/main" id="{E41304C9-BA3B-4F15-A66B-14C4C9EB169C}"/>
               </a:ext>
             </a:extLst>
           </p:cNvPr>
@@ -6115,7 +7675,7 @@
           <p:cNvPr id="2" name="">
             <a:extLst xmlns:a="http://schemas.openxmlformats.org/drawingml/2006/main">
               <a:ext uri="{FF2B5EF4-FFF2-40B4-BE49-F238E27FC236}">
-                <a16:creationId xmlns:a16="http://schemas.microsoft.com/office/drawing/2014/main" id="{FF12B9B1-626D-4B01-9F5F-40074DA3A08D}"/>
+                <a16:creationId xmlns:a16="http://schemas.microsoft.com/office/drawing/2014/main" id="{8A713EC3-F7E7-4858-97AF-8D18D0DFA9EF}"/>
               </a:ext>
             </a:extLst>
           </p:cNvPr>
@@ -6172,7 +7732,7 @@
           <p:cNvPr id="3" name="">
             <a:extLst xmlns:a="http://schemas.openxmlformats.org/drawingml/2006/main">
               <a:ext uri="{FF2B5EF4-FFF2-40B4-BE49-F238E27FC236}">
-                <a16:creationId xmlns:a16="http://schemas.microsoft.com/office/drawing/2014/main" id="{D199E73A-28F0-4686-884D-347FC776C393}"/>
+                <a16:creationId xmlns:a16="http://schemas.microsoft.com/office/drawing/2014/main" id="{7418F99E-FE7C-4112-8FF8-E92EA14B8DE4}"/>
               </a:ext>
             </a:extLst>
           </p:cNvPr>
@@ -6229,7 +7789,7 @@
           <p:cNvPr id="4" name="">
             <a:extLst xmlns:a="http://schemas.openxmlformats.org/drawingml/2006/main">
               <a:ext uri="{FF2B5EF4-FFF2-40B4-BE49-F238E27FC236}">
-                <a16:creationId xmlns:a16="http://schemas.microsoft.com/office/drawing/2014/main" id="{33378C11-947B-4126-B933-66A23D932819}"/>
+                <a16:creationId xmlns:a16="http://schemas.microsoft.com/office/drawing/2014/main" id="{9E34583B-AD66-4E25-A7FF-9658B7718172}"/>
               </a:ext>
             </a:extLst>
           </p:cNvPr>
@@ -6332,7 +7892,7 @@
           <p:cNvPr id="5" name="">
             <a:extLst xmlns:a="http://schemas.openxmlformats.org/drawingml/2006/main">
               <a:ext uri="{FF2B5EF4-FFF2-40B4-BE49-F238E27FC236}">
-                <a16:creationId xmlns:a16="http://schemas.microsoft.com/office/drawing/2014/main" id="{44EC7D56-7F46-4BC7-B506-CFD0BF8DCBE5}"/>
+                <a16:creationId xmlns:a16="http://schemas.microsoft.com/office/drawing/2014/main" id="{4B7FF70F-10C5-49AA-9A31-FF77E77B6B96}"/>
               </a:ext>
             </a:extLst>
           </p:cNvPr>
@@ -6412,7 +7972,7 @@
           <p:cNvPr id="6" name="">
             <a:extLst xmlns:a="http://schemas.openxmlformats.org/drawingml/2006/main">
               <a:ext uri="{FF2B5EF4-FFF2-40B4-BE49-F238E27FC236}">
-                <a16:creationId xmlns:a16="http://schemas.microsoft.com/office/drawing/2014/main" id="{037BAD61-4263-4492-BE1E-13D38DC753D6}"/>
+                <a16:creationId xmlns:a16="http://schemas.microsoft.com/office/drawing/2014/main" id="{486412AD-60A7-4926-98B7-2321CBC772FE}"/>
               </a:ext>
             </a:extLst>
           </p:cNvPr>
@@ -6467,7 +8027,7 @@
     </p:spTree>
     <p:extLst>
       <p:ext uri="{BB962C8B-B14F-4D97-AF65-F5344CB8AC3E}">
-        <p14:creationId xmlns:p14="http://schemas.microsoft.com/office/powerpoint/2010/main" val="245255696"/>
+        <p14:creationId xmlns:p14="http://schemas.microsoft.com/office/powerpoint/2010/main" val="1709278854"/>
       </p:ext>
     </p:extLst>
   </p:cSld>

</xml_diff>